<commit_message>
Benchmark pass: add 2026-current content and close design gaps
After benchmarking vs comparable accessible courses and top university
offerings, add the high-value improvements reviewers identified:
- Week 9: reasoning models / test-time compute + context-engineering framing
- Week 11: modern RAG (hybrid search + reranking + Contextual Retrieval +
  agentic RAG) with a hands-on hybrid/rerank notebook
- Week 13: hands-on MCP server/client notebook, agent-memory taxonomy, MCP
  security, guardrails wired into the deployable Flask app, max_turns demo
- Week 16: post-training ladder (SFT -> DPO -> GRPO) named
- Week 17: judge-bias coverage + broadened Responsible AI section
- Week 15: provenance/watermarking (SynthID, C2PA)
- Week 5: self-check asserts, k-NN scaling demo, coefficient interpretation
- Week 8: de-risked pacing (concepts-first framing, lighter capstone start)
- Responsible AI added as an explicit course objective; model IDs normalized
</commit_message>
<xml_diff>
--- a/CSCI250-Fall2026/content/Week05_Regression-Classification/slides.pptx
+++ b/CSCI250-Fall2026/content/Week05_Regression-Classification/slides.pptx
@@ -19,6 +19,8 @@
     <p:sldId id="267" r:id="rId18"/>
     <p:sldId id="268" r:id="rId19"/>
     <p:sldId id="269" r:id="rId20"/>
+    <p:sldId id="270" r:id="rId21"/>
+    <p:sldId id="271" r:id="rId22"/>
   </p:sldIdLst>
   <p:sldSz cx="12191695" cy="6858000" type="screen4x3"/>
   <p:notesSz cx="6858000" cy="9144000"/>
@@ -3237,7 +3239,7 @@
     <p:bg>
       <p:bgPr>
         <a:solidFill>
-          <a:srgbClr val="128C8C"/>
+          <a:srgbClr val="FFFFFF"/>
         </a:solidFill>
         <a:effectLst/>
       </p:bgPr>
@@ -3251,14 +3253,102 @@
       <p:grpSpPr/>
       <p:sp>
         <p:nvSpPr>
-          <p:cNvPr id="2" name="TextBox 1"/>
+          <p:cNvPr id="2" name="Rectangle 1"/>
+          <p:cNvSpPr/>
+          <p:nvPr/>
+        </p:nvSpPr>
+        <p:spPr>
+          <a:xfrm>
+            <a:off x="0" y="0"/>
+            <a:ext cx="12191695" cy="1051560"/>
+          </a:xfrm>
+          <a:prstGeom prst="rect">
+            <a:avLst/>
+          </a:prstGeom>
+          <a:solidFill>
+            <a:srgbClr val="0B1F3A"/>
+          </a:solidFill>
+          <a:ln>
+            <a:noFill/>
+          </a:ln>
+          <a:effectLst/>
+        </p:spPr>
+        <p:style>
+          <a:lnRef idx="1">
+            <a:schemeClr val="accent1"/>
+          </a:lnRef>
+          <a:fillRef idx="3">
+            <a:schemeClr val="accent1"/>
+          </a:fillRef>
+          <a:effectRef idx="2">
+            <a:schemeClr val="accent1"/>
+          </a:effectRef>
+          <a:fontRef idx="minor">
+            <a:schemeClr val="lt1"/>
+          </a:fontRef>
+        </p:style>
+        <p:txBody>
+          <a:bodyPr rtlCol="0" anchor="ctr"/>
+          <a:lstStyle/>
+          <a:p>
+            <a:pPr algn="ctr"/>
+          </a:p>
+        </p:txBody>
+      </p:sp>
+      <p:sp>
+        <p:nvSpPr>
+          <p:cNvPr id="3" name="Rectangle 2"/>
+          <p:cNvSpPr/>
+          <p:nvPr/>
+        </p:nvSpPr>
+        <p:spPr>
+          <a:xfrm>
+            <a:off x="0" y="1051560"/>
+            <a:ext cx="12191695" cy="54864"/>
+          </a:xfrm>
+          <a:prstGeom prst="rect">
+            <a:avLst/>
+          </a:prstGeom>
+          <a:solidFill>
+            <a:srgbClr val="128C8C"/>
+          </a:solidFill>
+          <a:ln>
+            <a:noFill/>
+          </a:ln>
+          <a:effectLst/>
+        </p:spPr>
+        <p:style>
+          <a:lnRef idx="1">
+            <a:schemeClr val="accent1"/>
+          </a:lnRef>
+          <a:fillRef idx="3">
+            <a:schemeClr val="accent1"/>
+          </a:fillRef>
+          <a:effectRef idx="2">
+            <a:schemeClr val="accent1"/>
+          </a:effectRef>
+          <a:fontRef idx="minor">
+            <a:schemeClr val="lt1"/>
+          </a:fontRef>
+        </p:style>
+        <p:txBody>
+          <a:bodyPr rtlCol="0" anchor="ctr"/>
+          <a:lstStyle/>
+          <a:p>
+            <a:pPr algn="ctr"/>
+          </a:p>
+        </p:txBody>
+      </p:sp>
+      <p:sp>
+        <p:nvSpPr>
+          <p:cNvPr id="4" name="TextBox 3"/>
           <p:cNvSpPr txBox="1"/>
           <p:nvPr/>
         </p:nvSpPr>
         <p:spPr>
           <a:xfrm>
-            <a:off x="822960" y="2743200"/>
-            <a:ext cx="10515600" cy="1371600"/>
+            <a:off x="548640" y="201168"/>
+            <a:ext cx="11064240" cy="731520"/>
           </a:xfrm>
           <a:prstGeom prst="rect">
             <a:avLst/>
@@ -3273,13 +3363,186 @@
           <a:p>
             <a:pPr algn="l"/>
             <a:r>
-              <a:rPr sz="3600" b="1">
+              <a:rPr sz="2800" b="1">
                 <a:solidFill>
                   <a:srgbClr val="FFFFFF"/>
                 </a:solidFill>
                 <a:latin typeface="Calibri"/>
               </a:rPr>
-              <a:t>Generalization: Train / Val / Test</a:t>
+              <a:t>When Accuracy Lies</a:t>
+            </a:r>
+          </a:p>
+        </p:txBody>
+      </p:sp>
+      <p:sp>
+        <p:nvSpPr>
+          <p:cNvPr id="5" name="TextBox 4"/>
+          <p:cNvSpPr txBox="1"/>
+          <p:nvPr/>
+        </p:nvSpPr>
+        <p:spPr>
+          <a:xfrm>
+            <a:off x="731520" y="1371600"/>
+            <a:ext cx="10698480" cy="4754880"/>
+          </a:xfrm>
+          <a:prstGeom prst="rect">
+            <a:avLst/>
+          </a:prstGeom>
+          <a:noFill/>
+        </p:spPr>
+        <p:txBody>
+          <a:bodyPr wrap="square">
+            <a:spAutoFit/>
+          </a:bodyPr>
+          <a:lstStyle/>
+          <a:p>
+            <a:pPr>
+              <a:spcAft>
+                <a:spcPts val="800"/>
+              </a:spcAft>
+            </a:pPr>
+            <a:r>
+              <a:rPr sz="2000">
+                <a:solidFill>
+                  <a:srgbClr val="1A1A1A"/>
+                </a:solidFill>
+                <a:latin typeface="Calibri"/>
+              </a:rPr>
+              <a:t>• Accuracy = fraction correct — fine only if classes are balanced</a:t>
+            </a:r>
+          </a:p>
+          <a:p>
+            <a:pPr>
+              <a:spcAft>
+                <a:spcPts val="800"/>
+              </a:spcAft>
+            </a:pPr>
+            <a:r>
+              <a:rPr sz="2000">
+                <a:solidFill>
+                  <a:srgbClr val="1A1A1A"/>
+                </a:solidFill>
+                <a:latin typeface="Calibri"/>
+              </a:rPr>
+              <a:t>• 99% not-spam? 'always not-spam' = 99% accurate and useless</a:t>
+            </a:r>
+          </a:p>
+          <a:p>
+            <a:pPr>
+              <a:spcAft>
+                <a:spcPts val="800"/>
+              </a:spcAft>
+            </a:pPr>
+            <a:r>
+              <a:rPr sz="2000">
+                <a:solidFill>
+                  <a:srgbClr val="1A1A1A"/>
+                </a:solidFill>
+                <a:latin typeface="Calibri"/>
+              </a:rPr>
+              <a:t>• Precision = of flagged positives, how many were right</a:t>
+            </a:r>
+          </a:p>
+          <a:p>
+            <a:pPr>
+              <a:spcAft>
+                <a:spcPts val="800"/>
+              </a:spcAft>
+            </a:pPr>
+            <a:r>
+              <a:rPr sz="2000">
+                <a:solidFill>
+                  <a:srgbClr val="1A1A1A"/>
+                </a:solidFill>
+                <a:latin typeface="Calibri"/>
+              </a:rPr>
+              <a:t>• Recall = of actual positives, how many we caught</a:t>
+            </a:r>
+          </a:p>
+          <a:p>
+            <a:pPr lvl="1">
+              <a:spcAft>
+                <a:spcPts val="800"/>
+              </a:spcAft>
+            </a:pPr>
+            <a:r>
+              <a:rPr sz="1800">
+                <a:solidFill>
+                  <a:srgbClr val="6B7280"/>
+                </a:solidFill>
+                <a:latin typeface="Calibri"/>
+              </a:rPr>
+              <a:t>– F1 = harmonic mean of precision &amp; recall (one number)</a:t>
+            </a:r>
+          </a:p>
+        </p:txBody>
+      </p:sp>
+      <p:sp>
+        <p:nvSpPr>
+          <p:cNvPr id="6" name="TextBox 5"/>
+          <p:cNvSpPr txBox="1"/>
+          <p:nvPr/>
+        </p:nvSpPr>
+        <p:spPr>
+          <a:xfrm>
+            <a:off x="365760" y="6446520"/>
+            <a:ext cx="8229600" cy="365760"/>
+          </a:xfrm>
+          <a:prstGeom prst="rect">
+            <a:avLst/>
+          </a:prstGeom>
+          <a:noFill/>
+        </p:spPr>
+        <p:txBody>
+          <a:bodyPr wrap="square">
+            <a:spAutoFit/>
+          </a:bodyPr>
+          <a:lstStyle/>
+          <a:p>
+            <a:pPr algn="l"/>
+            <a:r>
+              <a:rPr sz="1000" b="0">
+                <a:solidFill>
+                  <a:srgbClr val="6B7280"/>
+                </a:solidFill>
+                <a:latin typeface="Calibri"/>
+              </a:rPr>
+              <a:t>Palomar College · CSCI 250 · Fall 2026</a:t>
+            </a:r>
+          </a:p>
+        </p:txBody>
+      </p:sp>
+      <p:sp>
+        <p:nvSpPr>
+          <p:cNvPr id="7" name="TextBox 6"/>
+          <p:cNvSpPr txBox="1"/>
+          <p:nvPr/>
+        </p:nvSpPr>
+        <p:spPr>
+          <a:xfrm>
+            <a:off x="11155680" y="6446520"/>
+            <a:ext cx="822960" cy="365760"/>
+          </a:xfrm>
+          <a:prstGeom prst="rect">
+            <a:avLst/>
+          </a:prstGeom>
+          <a:noFill/>
+        </p:spPr>
+        <p:txBody>
+          <a:bodyPr wrap="square">
+            <a:spAutoFit/>
+          </a:bodyPr>
+          <a:lstStyle/>
+          <a:p>
+            <a:pPr algn="r"/>
+            <a:r>
+              <a:rPr sz="1000" b="0">
+                <a:solidFill>
+                  <a:srgbClr val="6B7280"/>
+                </a:solidFill>
+                <a:latin typeface="Calibri"/>
+              </a:rPr>
+              <a:t>10/16</a:t>
             </a:r>
           </a:p>
         </p:txBody>
@@ -3428,21 +3691,140 @@
                 </a:solidFill>
                 <a:latin typeface="Calibri"/>
               </a:rPr>
-              <a:t>Three Splits, One Rule</a:t>
-            </a:r>
-          </a:p>
-        </p:txBody>
-      </p:sp>
-      <p:sp>
-        <p:nvSpPr>
-          <p:cNvPr id="5" name="TextBox 4"/>
+              <a:t>Classifier Metrics in sklearn</a:t>
+            </a:r>
+          </a:p>
+        </p:txBody>
+      </p:sp>
+      <p:sp>
+        <p:nvSpPr>
+          <p:cNvPr id="5" name="Rectangle 4"/>
+          <p:cNvSpPr/>
+          <p:nvPr/>
+        </p:nvSpPr>
+        <p:spPr>
+          <a:xfrm>
+            <a:off x="548640" y="1325880"/>
+            <a:ext cx="11064240" cy="4480560"/>
+          </a:xfrm>
+          <a:prstGeom prst="rect">
+            <a:avLst/>
+          </a:prstGeom>
+          <a:solidFill>
+            <a:srgbClr val="1E1E1E"/>
+          </a:solidFill>
+          <a:ln>
+            <a:noFill/>
+          </a:ln>
+          <a:effectLst/>
+        </p:spPr>
+        <p:style>
+          <a:lnRef idx="1">
+            <a:schemeClr val="accent1"/>
+          </a:lnRef>
+          <a:fillRef idx="3">
+            <a:schemeClr val="accent1"/>
+          </a:fillRef>
+          <a:effectRef idx="2">
+            <a:schemeClr val="accent1"/>
+          </a:effectRef>
+          <a:fontRef idx="minor">
+            <a:schemeClr val="lt1"/>
+          </a:fontRef>
+        </p:style>
+        <p:txBody>
+          <a:bodyPr rtlCol="0" anchor="ctr" wrap="square" lIns="182880" tIns="137160"/>
+          <a:lstStyle/>
+          <a:p>
+            <a:pPr algn="ctr"/>
+            <a:r>
+              <a:rPr sz="1500">
+                <a:solidFill>
+                  <a:srgbClr val="E6E6E6"/>
+                </a:solidFill>
+                <a:latin typeface="Consolas"/>
+              </a:rPr>
+              <a:t>from sklearn.metrics import (classification_report,</a:t>
+            </a:r>
+          </a:p>
+          <a:p>
+            <a:r>
+              <a:rPr sz="1500">
+                <a:solidFill>
+                  <a:srgbClr val="E6E6E6"/>
+                </a:solidFill>
+                <a:latin typeface="Consolas"/>
+              </a:rPr>
+              <a:t>                             confusion_matrix)</a:t>
+            </a:r>
+          </a:p>
+          <a:p>
+            <a:r>
+              <a:rPr sz="1500">
+                <a:solidFill>
+                  <a:srgbClr val="E6E6E6"/>
+                </a:solidFill>
+                <a:latin typeface="Consolas"/>
+              </a:rPr>
+              <a:t> </a:t>
+            </a:r>
+          </a:p>
+          <a:p>
+            <a:r>
+              <a:rPr sz="1500">
+                <a:solidFill>
+                  <a:srgbClr val="E6E6E6"/>
+                </a:solidFill>
+                <a:latin typeface="Consolas"/>
+              </a:rPr>
+              <a:t>clf.fit(X_train, y_train)</a:t>
+            </a:r>
+          </a:p>
+          <a:p>
+            <a:r>
+              <a:rPr sz="1500">
+                <a:solidFill>
+                  <a:srgbClr val="E6E6E6"/>
+                </a:solidFill>
+                <a:latin typeface="Consolas"/>
+              </a:rPr>
+              <a:t>p = clf.predict(X_test)</a:t>
+            </a:r>
+          </a:p>
+          <a:p>
+            <a:r>
+              <a:rPr sz="1500">
+                <a:solidFill>
+                  <a:srgbClr val="E6E6E6"/>
+                </a:solidFill>
+                <a:latin typeface="Consolas"/>
+              </a:rPr>
+              <a:t>print(classification_report(y_test, p))</a:t>
+            </a:r>
+          </a:p>
+          <a:p>
+            <a:r>
+              <a:rPr sz="1500">
+                <a:solidFill>
+                  <a:srgbClr val="E6E6E6"/>
+                </a:solidFill>
+                <a:latin typeface="Consolas"/>
+              </a:rPr>
+              <a:t>print(confusion_matrix(y_test, p))</a:t>
+            </a:r>
+          </a:p>
+        </p:txBody>
+      </p:sp>
+      <p:sp>
+        <p:nvSpPr>
+          <p:cNvPr id="6" name="TextBox 5"/>
           <p:cNvSpPr txBox="1"/>
           <p:nvPr/>
         </p:nvSpPr>
         <p:spPr>
           <a:xfrm>
-            <a:off x="731520" y="1371600"/>
-            <a:ext cx="10698480" cy="4754880"/>
+            <a:off x="548640" y="5897880"/>
+            <a:ext cx="10515600" cy="457200"/>
           </a:xfrm>
           <a:prstGeom prst="rect">
             <a:avLst/>
@@ -3455,74 +3837,22 @@
           </a:bodyPr>
           <a:lstStyle/>
           <a:p>
-            <a:pPr>
-              <a:spcAft>
-                <a:spcPts val="800"/>
-              </a:spcAft>
-            </a:pPr>
-            <a:r>
-              <a:rPr sz="2000">
-                <a:solidFill>
-                  <a:srgbClr val="1A1A1A"/>
-                </a:solidFill>
-                <a:latin typeface="Calibri"/>
-              </a:rPr>
-              <a:t>• Train — fit the model</a:t>
-            </a:r>
-          </a:p>
-          <a:p>
-            <a:pPr>
-              <a:spcAft>
-                <a:spcPts val="800"/>
-              </a:spcAft>
-            </a:pPr>
-            <a:r>
-              <a:rPr sz="2000">
-                <a:solidFill>
-                  <a:srgbClr val="1A1A1A"/>
-                </a:solidFill>
-                <a:latin typeface="Calibri"/>
-              </a:rPr>
-              <a:t>• Validation — tune model &amp; hyperparameters</a:t>
-            </a:r>
-          </a:p>
-          <a:p>
-            <a:pPr>
-              <a:spcAft>
-                <a:spcPts val="800"/>
-              </a:spcAft>
-            </a:pPr>
-            <a:r>
-              <a:rPr sz="2000">
-                <a:solidFill>
-                  <a:srgbClr val="1A1A1A"/>
-                </a:solidFill>
-                <a:latin typeface="Calibri"/>
-              </a:rPr>
-              <a:t>• Test — touched ONCE, at the end, for an honest score</a:t>
-            </a:r>
-          </a:p>
-          <a:p>
-            <a:pPr lvl="1">
-              <a:spcAft>
-                <a:spcPts val="800"/>
-              </a:spcAft>
-            </a:pPr>
-            <a:r>
-              <a:rPr sz="1800">
+            <a:pPr algn="l"/>
+            <a:r>
+              <a:rPr sz="1400" b="0">
                 <a:solidFill>
                   <a:srgbClr val="6B7280"/>
                 </a:solidFill>
                 <a:latin typeface="Calibri"/>
               </a:rPr>
-              <a:t>– Small data? Use cross_val_score(model, X, y, cv=5) instead</a:t>
-            </a:r>
-          </a:p>
-        </p:txBody>
-      </p:sp>
-      <p:sp>
-        <p:nvSpPr>
-          <p:cNvPr id="6" name="TextBox 5"/>
+              <a:t>Confusion matrix shows WHICH classes get confused — not just how many</a:t>
+            </a:r>
+          </a:p>
+        </p:txBody>
+      </p:sp>
+      <p:sp>
+        <p:nvSpPr>
+          <p:cNvPr id="7" name="TextBox 6"/>
           <p:cNvSpPr txBox="1"/>
           <p:nvPr/>
         </p:nvSpPr>
@@ -3557,7 +3887,7 @@
       </p:sp>
       <p:sp>
         <p:nvSpPr>
-          <p:cNvPr id="7" name="TextBox 6"/>
+          <p:cNvPr id="8" name="TextBox 7"/>
           <p:cNvSpPr txBox="1"/>
           <p:nvPr/>
         </p:nvSpPr>
@@ -3585,7 +3915,7 @@
                 </a:solidFill>
                 <a:latin typeface="Calibri"/>
               </a:rPr>
-              <a:t>11/14</a:t>
+              <a:t>11/16</a:t>
             </a:r>
           </a:p>
         </p:txBody>
@@ -3604,7 +3934,7 @@
     <p:bg>
       <p:bgPr>
         <a:solidFill>
-          <a:srgbClr val="FFFFFF"/>
+          <a:srgbClr val="128C8C"/>
         </a:solidFill>
         <a:effectLst/>
       </p:bgPr>
@@ -3618,102 +3948,14 @@
       <p:grpSpPr/>
       <p:sp>
         <p:nvSpPr>
-          <p:cNvPr id="2" name="Rectangle 1"/>
-          <p:cNvSpPr/>
-          <p:nvPr/>
-        </p:nvSpPr>
-        <p:spPr>
-          <a:xfrm>
-            <a:off x="0" y="0"/>
-            <a:ext cx="12191695" cy="1051560"/>
-          </a:xfrm>
-          <a:prstGeom prst="rect">
-            <a:avLst/>
-          </a:prstGeom>
-          <a:solidFill>
-            <a:srgbClr val="0B1F3A"/>
-          </a:solidFill>
-          <a:ln>
-            <a:noFill/>
-          </a:ln>
-          <a:effectLst/>
-        </p:spPr>
-        <p:style>
-          <a:lnRef idx="1">
-            <a:schemeClr val="accent1"/>
-          </a:lnRef>
-          <a:fillRef idx="3">
-            <a:schemeClr val="accent1"/>
-          </a:fillRef>
-          <a:effectRef idx="2">
-            <a:schemeClr val="accent1"/>
-          </a:effectRef>
-          <a:fontRef idx="minor">
-            <a:schemeClr val="lt1"/>
-          </a:fontRef>
-        </p:style>
-        <p:txBody>
-          <a:bodyPr rtlCol="0" anchor="ctr"/>
-          <a:lstStyle/>
-          <a:p>
-            <a:pPr algn="ctr"/>
-          </a:p>
-        </p:txBody>
-      </p:sp>
-      <p:sp>
-        <p:nvSpPr>
-          <p:cNvPr id="3" name="Rectangle 2"/>
-          <p:cNvSpPr/>
-          <p:nvPr/>
-        </p:nvSpPr>
-        <p:spPr>
-          <a:xfrm>
-            <a:off x="0" y="1051560"/>
-            <a:ext cx="12191695" cy="54864"/>
-          </a:xfrm>
-          <a:prstGeom prst="rect">
-            <a:avLst/>
-          </a:prstGeom>
-          <a:solidFill>
-            <a:srgbClr val="128C8C"/>
-          </a:solidFill>
-          <a:ln>
-            <a:noFill/>
-          </a:ln>
-          <a:effectLst/>
-        </p:spPr>
-        <p:style>
-          <a:lnRef idx="1">
-            <a:schemeClr val="accent1"/>
-          </a:lnRef>
-          <a:fillRef idx="3">
-            <a:schemeClr val="accent1"/>
-          </a:fillRef>
-          <a:effectRef idx="2">
-            <a:schemeClr val="accent1"/>
-          </a:effectRef>
-          <a:fontRef idx="minor">
-            <a:schemeClr val="lt1"/>
-          </a:fontRef>
-        </p:style>
-        <p:txBody>
-          <a:bodyPr rtlCol="0" anchor="ctr"/>
-          <a:lstStyle/>
-          <a:p>
-            <a:pPr algn="ctr"/>
-          </a:p>
-        </p:txBody>
-      </p:sp>
-      <p:sp>
-        <p:nvSpPr>
-          <p:cNvPr id="4" name="TextBox 3"/>
+          <p:cNvPr id="2" name="TextBox 1"/>
           <p:cNvSpPr txBox="1"/>
           <p:nvPr/>
         </p:nvSpPr>
         <p:spPr>
           <a:xfrm>
-            <a:off x="548640" y="201168"/>
-            <a:ext cx="11064240" cy="731520"/>
+            <a:off x="822960" y="2743200"/>
+            <a:ext cx="10515600" cy="1371600"/>
           </a:xfrm>
           <a:prstGeom prst="rect">
             <a:avLst/>
@@ -3728,295 +3970,13 @@
           <a:p>
             <a:pPr algn="l"/>
             <a:r>
-              <a:rPr sz="2800" b="1">
+              <a:rPr sz="3600" b="1">
                 <a:solidFill>
                   <a:srgbClr val="FFFFFF"/>
                 </a:solidFill>
                 <a:latin typeface="Calibri"/>
               </a:rPr>
-              <a:t>Overfit vs Underfit</a:t>
-            </a:r>
-          </a:p>
-        </p:txBody>
-      </p:sp>
-      <p:sp>
-        <p:nvSpPr>
-          <p:cNvPr id="5" name="TextBox 4"/>
-          <p:cNvSpPr txBox="1"/>
-          <p:nvPr/>
-        </p:nvSpPr>
-        <p:spPr>
-          <a:xfrm>
-            <a:off x="731520" y="1280160"/>
-            <a:ext cx="5120640" cy="548640"/>
-          </a:xfrm>
-          <a:prstGeom prst="rect">
-            <a:avLst/>
-          </a:prstGeom>
-          <a:noFill/>
-        </p:spPr>
-        <p:txBody>
-          <a:bodyPr wrap="square">
-            <a:spAutoFit/>
-          </a:bodyPr>
-          <a:lstStyle/>
-          <a:p>
-            <a:pPr algn="l"/>
-            <a:r>
-              <a:rPr sz="2000" b="1">
-                <a:solidFill>
-                  <a:srgbClr val="128C8C"/>
-                </a:solidFill>
-                <a:latin typeface="Calibri"/>
-              </a:rPr>
-              <a:t>Overfitting</a:t>
-            </a:r>
-          </a:p>
-        </p:txBody>
-      </p:sp>
-      <p:sp>
-        <p:nvSpPr>
-          <p:cNvPr id="6" name="TextBox 5"/>
-          <p:cNvSpPr txBox="1"/>
-          <p:nvPr/>
-        </p:nvSpPr>
-        <p:spPr>
-          <a:xfrm>
-            <a:off x="731520" y="1828800"/>
-            <a:ext cx="5120640" cy="4206240"/>
-          </a:xfrm>
-          <a:prstGeom prst="rect">
-            <a:avLst/>
-          </a:prstGeom>
-          <a:noFill/>
-        </p:spPr>
-        <p:txBody>
-          <a:bodyPr wrap="square">
-            <a:spAutoFit/>
-          </a:bodyPr>
-          <a:lstStyle/>
-          <a:p>
-            <a:pPr>
-              <a:spcAft>
-                <a:spcPts val="800"/>
-              </a:spcAft>
-            </a:pPr>
-            <a:r>
-              <a:rPr sz="1800">
-                <a:solidFill>
-                  <a:srgbClr val="1A1A1A"/>
-                </a:solidFill>
-                <a:latin typeface="Calibri"/>
-              </a:rPr>
-              <a:t>• Memorizes training noise</a:t>
-            </a:r>
-          </a:p>
-          <a:p>
-            <a:pPr>
-              <a:spcAft>
-                <a:spcPts val="800"/>
-              </a:spcAft>
-            </a:pPr>
-            <a:r>
-              <a:rPr sz="1800">
-                <a:solidFill>
-                  <a:srgbClr val="1A1A1A"/>
-                </a:solidFill>
-                <a:latin typeface="Calibri"/>
-              </a:rPr>
-              <a:t>• Great on train, poor on test</a:t>
-            </a:r>
-          </a:p>
-          <a:p>
-            <a:pPr>
-              <a:spcAft>
-                <a:spcPts val="800"/>
-              </a:spcAft>
-            </a:pPr>
-            <a:r>
-              <a:rPr sz="1800">
-                <a:solidFill>
-                  <a:srgbClr val="1A1A1A"/>
-                </a:solidFill>
-                <a:latin typeface="Calibri"/>
-              </a:rPr>
-              <a:t>• Big train↔test gap</a:t>
-            </a:r>
-          </a:p>
-        </p:txBody>
-      </p:sp>
-      <p:sp>
-        <p:nvSpPr>
-          <p:cNvPr id="7" name="TextBox 6"/>
-          <p:cNvSpPr txBox="1"/>
-          <p:nvPr/>
-        </p:nvSpPr>
-        <p:spPr>
-          <a:xfrm>
-            <a:off x="6309360" y="1280160"/>
-            <a:ext cx="5120640" cy="548640"/>
-          </a:xfrm>
-          <a:prstGeom prst="rect">
-            <a:avLst/>
-          </a:prstGeom>
-          <a:noFill/>
-        </p:spPr>
-        <p:txBody>
-          <a:bodyPr wrap="square">
-            <a:spAutoFit/>
-          </a:bodyPr>
-          <a:lstStyle/>
-          <a:p>
-            <a:pPr algn="l"/>
-            <a:r>
-              <a:rPr sz="2000" b="1">
-                <a:solidFill>
-                  <a:srgbClr val="128C8C"/>
-                </a:solidFill>
-                <a:latin typeface="Calibri"/>
-              </a:rPr>
-              <a:t>Underfitting</a:t>
-            </a:r>
-          </a:p>
-        </p:txBody>
-      </p:sp>
-      <p:sp>
-        <p:nvSpPr>
-          <p:cNvPr id="8" name="TextBox 7"/>
-          <p:cNvSpPr txBox="1"/>
-          <p:nvPr/>
-        </p:nvSpPr>
-        <p:spPr>
-          <a:xfrm>
-            <a:off x="6309360" y="1828800"/>
-            <a:ext cx="5120640" cy="4206240"/>
-          </a:xfrm>
-          <a:prstGeom prst="rect">
-            <a:avLst/>
-          </a:prstGeom>
-          <a:noFill/>
-        </p:spPr>
-        <p:txBody>
-          <a:bodyPr wrap="square">
-            <a:spAutoFit/>
-          </a:bodyPr>
-          <a:lstStyle/>
-          <a:p>
-            <a:pPr>
-              <a:spcAft>
-                <a:spcPts val="800"/>
-              </a:spcAft>
-            </a:pPr>
-            <a:r>
-              <a:rPr sz="1800">
-                <a:solidFill>
-                  <a:srgbClr val="1A1A1A"/>
-                </a:solidFill>
-                <a:latin typeface="Calibri"/>
-              </a:rPr>
-              <a:t>• Too simple for the pattern</a:t>
-            </a:r>
-          </a:p>
-          <a:p>
-            <a:pPr>
-              <a:spcAft>
-                <a:spcPts val="800"/>
-              </a:spcAft>
-            </a:pPr>
-            <a:r>
-              <a:rPr sz="1800">
-                <a:solidFill>
-                  <a:srgbClr val="1A1A1A"/>
-                </a:solidFill>
-                <a:latin typeface="Calibri"/>
-              </a:rPr>
-              <a:t>• Poor on BOTH train &amp; test</a:t>
-            </a:r>
-          </a:p>
-          <a:p>
-            <a:pPr>
-              <a:spcAft>
-                <a:spcPts val="800"/>
-              </a:spcAft>
-            </a:pPr>
-            <a:r>
-              <a:rPr sz="1800">
-                <a:solidFill>
-                  <a:srgbClr val="1A1A1A"/>
-                </a:solidFill>
-                <a:latin typeface="Calibri"/>
-              </a:rPr>
-              <a:t>• e.g. a line for a curve</a:t>
-            </a:r>
-          </a:p>
-        </p:txBody>
-      </p:sp>
-      <p:sp>
-        <p:nvSpPr>
-          <p:cNvPr id="9" name="TextBox 8"/>
-          <p:cNvSpPr txBox="1"/>
-          <p:nvPr/>
-        </p:nvSpPr>
-        <p:spPr>
-          <a:xfrm>
-            <a:off x="365760" y="6446520"/>
-            <a:ext cx="8229600" cy="365760"/>
-          </a:xfrm>
-          <a:prstGeom prst="rect">
-            <a:avLst/>
-          </a:prstGeom>
-          <a:noFill/>
-        </p:spPr>
-        <p:txBody>
-          <a:bodyPr wrap="square">
-            <a:spAutoFit/>
-          </a:bodyPr>
-          <a:lstStyle/>
-          <a:p>
-            <a:pPr algn="l"/>
-            <a:r>
-              <a:rPr sz="1000" b="0">
-                <a:solidFill>
-                  <a:srgbClr val="6B7280"/>
-                </a:solidFill>
-                <a:latin typeface="Calibri"/>
-              </a:rPr>
-              <a:t>Palomar College · CSCI 250 · Fall 2026</a:t>
-            </a:r>
-          </a:p>
-        </p:txBody>
-      </p:sp>
-      <p:sp>
-        <p:nvSpPr>
-          <p:cNvPr id="10" name="TextBox 9"/>
-          <p:cNvSpPr txBox="1"/>
-          <p:nvPr/>
-        </p:nvSpPr>
-        <p:spPr>
-          <a:xfrm>
-            <a:off x="11155680" y="6446520"/>
-            <a:ext cx="822960" cy="365760"/>
-          </a:xfrm>
-          <a:prstGeom prst="rect">
-            <a:avLst/>
-          </a:prstGeom>
-          <a:noFill/>
-        </p:spPr>
-        <p:txBody>
-          <a:bodyPr wrap="square">
-            <a:spAutoFit/>
-          </a:bodyPr>
-          <a:lstStyle/>
-          <a:p>
-            <a:pPr algn="r"/>
-            <a:r>
-              <a:rPr sz="1000" b="0">
-                <a:solidFill>
-                  <a:srgbClr val="6B7280"/>
-                </a:solidFill>
-                <a:latin typeface="Calibri"/>
-              </a:rPr>
-              <a:t>12/14</a:t>
+              <a:t>Generalization: Train / Val / Test</a:t>
             </a:r>
           </a:p>
         </p:txBody>
@@ -4165,151 +4125,21 @@
                 </a:solidFill>
                 <a:latin typeface="Calibri"/>
               </a:rPr>
-              <a:t>Regularization Fights Overfitting</a:t>
-            </a:r>
-          </a:p>
-        </p:txBody>
-      </p:sp>
-      <p:sp>
-        <p:nvSpPr>
-          <p:cNvPr id="5" name="Rectangle 4"/>
-          <p:cNvSpPr/>
-          <p:nvPr/>
-        </p:nvSpPr>
-        <p:spPr>
-          <a:xfrm>
-            <a:off x="548640" y="1325880"/>
-            <a:ext cx="11064240" cy="4480560"/>
-          </a:xfrm>
-          <a:prstGeom prst="rect">
-            <a:avLst/>
-          </a:prstGeom>
-          <a:solidFill>
-            <a:srgbClr val="1E1E1E"/>
-          </a:solidFill>
-          <a:ln>
-            <a:noFill/>
-          </a:ln>
-          <a:effectLst/>
-        </p:spPr>
-        <p:style>
-          <a:lnRef idx="1">
-            <a:schemeClr val="accent1"/>
-          </a:lnRef>
-          <a:fillRef idx="3">
-            <a:schemeClr val="accent1"/>
-          </a:fillRef>
-          <a:effectRef idx="2">
-            <a:schemeClr val="accent1"/>
-          </a:effectRef>
-          <a:fontRef idx="minor">
-            <a:schemeClr val="lt1"/>
-          </a:fontRef>
-        </p:style>
-        <p:txBody>
-          <a:bodyPr rtlCol="0" anchor="ctr" wrap="square" lIns="182880" tIns="137160"/>
-          <a:lstStyle/>
-          <a:p>
-            <a:pPr algn="ctr"/>
-            <a:r>
-              <a:rPr sz="1500">
-                <a:solidFill>
-                  <a:srgbClr val="E6E6E6"/>
-                </a:solidFill>
-                <a:latin typeface="Consolas"/>
-              </a:rPr>
-              <a:t># smaller C = stronger regularization</a:t>
-            </a:r>
-          </a:p>
-          <a:p>
-            <a:r>
-              <a:rPr sz="1500">
-                <a:solidFill>
-                  <a:srgbClr val="E6E6E6"/>
-                </a:solidFill>
-                <a:latin typeface="Consolas"/>
-              </a:rPr>
-              <a:t>LogisticRegression(C=0.1)</a:t>
-            </a:r>
-          </a:p>
-          <a:p>
-            <a:r>
-              <a:rPr sz="1500">
-                <a:solidFill>
-                  <a:srgbClr val="E6E6E6"/>
-                </a:solidFill>
-                <a:latin typeface="Consolas"/>
-              </a:rPr>
-              <a:t> </a:t>
-            </a:r>
-          </a:p>
-          <a:p>
-            <a:r>
-              <a:rPr sz="1500">
-                <a:solidFill>
-                  <a:srgbClr val="E6E6E6"/>
-                </a:solidFill>
-                <a:latin typeface="Consolas"/>
-              </a:rPr>
-              <a:t># shallower tree = less overfitting</a:t>
-            </a:r>
-          </a:p>
-          <a:p>
-            <a:r>
-              <a:rPr sz="1500">
-                <a:solidFill>
-                  <a:srgbClr val="E6E6E6"/>
-                </a:solidFill>
-                <a:latin typeface="Consolas"/>
-              </a:rPr>
-              <a:t>DecisionTreeClassifier(max_depth=3)</a:t>
-            </a:r>
-          </a:p>
-          <a:p>
-            <a:r>
-              <a:rPr sz="1500">
-                <a:solidFill>
-                  <a:srgbClr val="E6E6E6"/>
-                </a:solidFill>
-                <a:latin typeface="Consolas"/>
-              </a:rPr>
-              <a:t> </a:t>
-            </a:r>
-          </a:p>
-          <a:p>
-            <a:r>
-              <a:rPr sz="1500">
-                <a:solidFill>
-                  <a:srgbClr val="E6E6E6"/>
-                </a:solidFill>
-                <a:latin typeface="Consolas"/>
-              </a:rPr>
-              <a:t># larger k = smoother boundary</a:t>
-            </a:r>
-          </a:p>
-          <a:p>
-            <a:r>
-              <a:rPr sz="1500">
-                <a:solidFill>
-                  <a:srgbClr val="E6E6E6"/>
-                </a:solidFill>
-                <a:latin typeface="Consolas"/>
-              </a:rPr>
-              <a:t>KNeighborsClassifier(n_neighbors=15)</a:t>
-            </a:r>
-          </a:p>
-        </p:txBody>
-      </p:sp>
-      <p:sp>
-        <p:nvSpPr>
-          <p:cNvPr id="6" name="TextBox 5"/>
+              <a:t>Three Splits, One Rule</a:t>
+            </a:r>
+          </a:p>
+        </p:txBody>
+      </p:sp>
+      <p:sp>
+        <p:nvSpPr>
+          <p:cNvPr id="5" name="TextBox 4"/>
           <p:cNvSpPr txBox="1"/>
           <p:nvPr/>
         </p:nvSpPr>
         <p:spPr>
           <a:xfrm>
-            <a:off x="548640" y="5897880"/>
-            <a:ext cx="10515600" cy="457200"/>
+            <a:off x="731520" y="1371600"/>
+            <a:ext cx="10698480" cy="4754880"/>
           </a:xfrm>
           <a:prstGeom prst="rect">
             <a:avLst/>
@@ -4322,22 +4152,74 @@
           </a:bodyPr>
           <a:lstStyle/>
           <a:p>
-            <a:pPr algn="l"/>
-            <a:r>
-              <a:rPr sz="1400" b="0">
+            <a:pPr>
+              <a:spcAft>
+                <a:spcPts val="800"/>
+              </a:spcAft>
+            </a:pPr>
+            <a:r>
+              <a:rPr sz="2000">
+                <a:solidFill>
+                  <a:srgbClr val="1A1A1A"/>
+                </a:solidFill>
+                <a:latin typeface="Calibri"/>
+              </a:rPr>
+              <a:t>• Train — fit the model</a:t>
+            </a:r>
+          </a:p>
+          <a:p>
+            <a:pPr>
+              <a:spcAft>
+                <a:spcPts val="800"/>
+              </a:spcAft>
+            </a:pPr>
+            <a:r>
+              <a:rPr sz="2000">
+                <a:solidFill>
+                  <a:srgbClr val="1A1A1A"/>
+                </a:solidFill>
+                <a:latin typeface="Calibri"/>
+              </a:rPr>
+              <a:t>• Validation — tune model &amp; hyperparameters</a:t>
+            </a:r>
+          </a:p>
+          <a:p>
+            <a:pPr>
+              <a:spcAft>
+                <a:spcPts val="800"/>
+              </a:spcAft>
+            </a:pPr>
+            <a:r>
+              <a:rPr sz="2000">
+                <a:solidFill>
+                  <a:srgbClr val="1A1A1A"/>
+                </a:solidFill>
+                <a:latin typeface="Calibri"/>
+              </a:rPr>
+              <a:t>• Test — touched ONCE, at the end, for an honest score</a:t>
+            </a:r>
+          </a:p>
+          <a:p>
+            <a:pPr lvl="1">
+              <a:spcAft>
+                <a:spcPts val="800"/>
+              </a:spcAft>
+            </a:pPr>
+            <a:r>
+              <a:rPr sz="1800">
                 <a:solidFill>
                   <a:srgbClr val="6B7280"/>
                 </a:solidFill>
                 <a:latin typeface="Calibri"/>
               </a:rPr>
-              <a:t>Tune for the train↔test GAP, not just the raw score</a:t>
-            </a:r>
-          </a:p>
-        </p:txBody>
-      </p:sp>
-      <p:sp>
-        <p:nvSpPr>
-          <p:cNvPr id="7" name="TextBox 6"/>
+              <a:t>– Small data? Use cross_val_score(model, X, y, cv=5) instead</a:t>
+            </a:r>
+          </a:p>
+        </p:txBody>
+      </p:sp>
+      <p:sp>
+        <p:nvSpPr>
+          <p:cNvPr id="6" name="TextBox 5"/>
           <p:cNvSpPr txBox="1"/>
           <p:nvPr/>
         </p:nvSpPr>
@@ -4372,7 +4254,7 @@
       </p:sp>
       <p:sp>
         <p:nvSpPr>
-          <p:cNvPr id="8" name="TextBox 7"/>
+          <p:cNvPr id="7" name="TextBox 6"/>
           <p:cNvSpPr txBox="1"/>
           <p:nvPr/>
         </p:nvSpPr>
@@ -4400,7 +4282,7 @@
                 </a:solidFill>
                 <a:latin typeface="Calibri"/>
               </a:rPr>
-              <a:t>13/14</a:t>
+              <a:t>13/16</a:t>
             </a:r>
           </a:p>
         </p:txBody>
@@ -4414,6 +4296,821 @@
 </file>
 
 <file path=ppt/slides/slide14.xml><?xml version="1.0" encoding="utf-8"?>
+<p:sld xmlns:a="http://schemas.openxmlformats.org/drawingml/2006/main" xmlns:p="http://schemas.openxmlformats.org/presentationml/2006/main" xmlns:r="http://schemas.openxmlformats.org/officeDocument/2006/relationships">
+  <p:cSld>
+    <p:bg>
+      <p:bgPr>
+        <a:solidFill>
+          <a:srgbClr val="FFFFFF"/>
+        </a:solidFill>
+        <a:effectLst/>
+      </p:bgPr>
+    </p:bg>
+    <p:spTree>
+      <p:nvGrpSpPr>
+        <p:cNvPr id="1" name=""/>
+        <p:cNvGrpSpPr/>
+        <p:nvPr/>
+      </p:nvGrpSpPr>
+      <p:grpSpPr/>
+      <p:sp>
+        <p:nvSpPr>
+          <p:cNvPr id="2" name="Rectangle 1"/>
+          <p:cNvSpPr/>
+          <p:nvPr/>
+        </p:nvSpPr>
+        <p:spPr>
+          <a:xfrm>
+            <a:off x="0" y="0"/>
+            <a:ext cx="12191695" cy="1051560"/>
+          </a:xfrm>
+          <a:prstGeom prst="rect">
+            <a:avLst/>
+          </a:prstGeom>
+          <a:solidFill>
+            <a:srgbClr val="0B1F3A"/>
+          </a:solidFill>
+          <a:ln>
+            <a:noFill/>
+          </a:ln>
+          <a:effectLst/>
+        </p:spPr>
+        <p:style>
+          <a:lnRef idx="1">
+            <a:schemeClr val="accent1"/>
+          </a:lnRef>
+          <a:fillRef idx="3">
+            <a:schemeClr val="accent1"/>
+          </a:fillRef>
+          <a:effectRef idx="2">
+            <a:schemeClr val="accent1"/>
+          </a:effectRef>
+          <a:fontRef idx="minor">
+            <a:schemeClr val="lt1"/>
+          </a:fontRef>
+        </p:style>
+        <p:txBody>
+          <a:bodyPr rtlCol="0" anchor="ctr"/>
+          <a:lstStyle/>
+          <a:p>
+            <a:pPr algn="ctr"/>
+          </a:p>
+        </p:txBody>
+      </p:sp>
+      <p:sp>
+        <p:nvSpPr>
+          <p:cNvPr id="3" name="Rectangle 2"/>
+          <p:cNvSpPr/>
+          <p:nvPr/>
+        </p:nvSpPr>
+        <p:spPr>
+          <a:xfrm>
+            <a:off x="0" y="1051560"/>
+            <a:ext cx="12191695" cy="54864"/>
+          </a:xfrm>
+          <a:prstGeom prst="rect">
+            <a:avLst/>
+          </a:prstGeom>
+          <a:solidFill>
+            <a:srgbClr val="128C8C"/>
+          </a:solidFill>
+          <a:ln>
+            <a:noFill/>
+          </a:ln>
+          <a:effectLst/>
+        </p:spPr>
+        <p:style>
+          <a:lnRef idx="1">
+            <a:schemeClr val="accent1"/>
+          </a:lnRef>
+          <a:fillRef idx="3">
+            <a:schemeClr val="accent1"/>
+          </a:fillRef>
+          <a:effectRef idx="2">
+            <a:schemeClr val="accent1"/>
+          </a:effectRef>
+          <a:fontRef idx="minor">
+            <a:schemeClr val="lt1"/>
+          </a:fontRef>
+        </p:style>
+        <p:txBody>
+          <a:bodyPr rtlCol="0" anchor="ctr"/>
+          <a:lstStyle/>
+          <a:p>
+            <a:pPr algn="ctr"/>
+          </a:p>
+        </p:txBody>
+      </p:sp>
+      <p:sp>
+        <p:nvSpPr>
+          <p:cNvPr id="4" name="TextBox 3"/>
+          <p:cNvSpPr txBox="1"/>
+          <p:nvPr/>
+        </p:nvSpPr>
+        <p:spPr>
+          <a:xfrm>
+            <a:off x="548640" y="201168"/>
+            <a:ext cx="11064240" cy="731520"/>
+          </a:xfrm>
+          <a:prstGeom prst="rect">
+            <a:avLst/>
+          </a:prstGeom>
+          <a:noFill/>
+        </p:spPr>
+        <p:txBody>
+          <a:bodyPr wrap="square" anchor="ctr">
+            <a:spAutoFit/>
+          </a:bodyPr>
+          <a:lstStyle/>
+          <a:p>
+            <a:pPr algn="l"/>
+            <a:r>
+              <a:rPr sz="2800" b="1">
+                <a:solidFill>
+                  <a:srgbClr val="FFFFFF"/>
+                </a:solidFill>
+                <a:latin typeface="Calibri"/>
+              </a:rPr>
+              <a:t>Overfit vs Underfit</a:t>
+            </a:r>
+          </a:p>
+        </p:txBody>
+      </p:sp>
+      <p:sp>
+        <p:nvSpPr>
+          <p:cNvPr id="5" name="TextBox 4"/>
+          <p:cNvSpPr txBox="1"/>
+          <p:nvPr/>
+        </p:nvSpPr>
+        <p:spPr>
+          <a:xfrm>
+            <a:off x="731520" y="1280160"/>
+            <a:ext cx="5120640" cy="548640"/>
+          </a:xfrm>
+          <a:prstGeom prst="rect">
+            <a:avLst/>
+          </a:prstGeom>
+          <a:noFill/>
+        </p:spPr>
+        <p:txBody>
+          <a:bodyPr wrap="square">
+            <a:spAutoFit/>
+          </a:bodyPr>
+          <a:lstStyle/>
+          <a:p>
+            <a:pPr algn="l"/>
+            <a:r>
+              <a:rPr sz="2000" b="1">
+                <a:solidFill>
+                  <a:srgbClr val="128C8C"/>
+                </a:solidFill>
+                <a:latin typeface="Calibri"/>
+              </a:rPr>
+              <a:t>Overfitting</a:t>
+            </a:r>
+          </a:p>
+        </p:txBody>
+      </p:sp>
+      <p:sp>
+        <p:nvSpPr>
+          <p:cNvPr id="6" name="TextBox 5"/>
+          <p:cNvSpPr txBox="1"/>
+          <p:nvPr/>
+        </p:nvSpPr>
+        <p:spPr>
+          <a:xfrm>
+            <a:off x="731520" y="1828800"/>
+            <a:ext cx="5120640" cy="4206240"/>
+          </a:xfrm>
+          <a:prstGeom prst="rect">
+            <a:avLst/>
+          </a:prstGeom>
+          <a:noFill/>
+        </p:spPr>
+        <p:txBody>
+          <a:bodyPr wrap="square">
+            <a:spAutoFit/>
+          </a:bodyPr>
+          <a:lstStyle/>
+          <a:p>
+            <a:pPr>
+              <a:spcAft>
+                <a:spcPts val="800"/>
+              </a:spcAft>
+            </a:pPr>
+            <a:r>
+              <a:rPr sz="1800">
+                <a:solidFill>
+                  <a:srgbClr val="1A1A1A"/>
+                </a:solidFill>
+                <a:latin typeface="Calibri"/>
+              </a:rPr>
+              <a:t>• Memorizes training noise</a:t>
+            </a:r>
+          </a:p>
+          <a:p>
+            <a:pPr>
+              <a:spcAft>
+                <a:spcPts val="800"/>
+              </a:spcAft>
+            </a:pPr>
+            <a:r>
+              <a:rPr sz="1800">
+                <a:solidFill>
+                  <a:srgbClr val="1A1A1A"/>
+                </a:solidFill>
+                <a:latin typeface="Calibri"/>
+              </a:rPr>
+              <a:t>• Great on train, poor on test</a:t>
+            </a:r>
+          </a:p>
+          <a:p>
+            <a:pPr>
+              <a:spcAft>
+                <a:spcPts val="800"/>
+              </a:spcAft>
+            </a:pPr>
+            <a:r>
+              <a:rPr sz="1800">
+                <a:solidFill>
+                  <a:srgbClr val="1A1A1A"/>
+                </a:solidFill>
+                <a:latin typeface="Calibri"/>
+              </a:rPr>
+              <a:t>• Big train↔test gap</a:t>
+            </a:r>
+          </a:p>
+        </p:txBody>
+      </p:sp>
+      <p:sp>
+        <p:nvSpPr>
+          <p:cNvPr id="7" name="TextBox 6"/>
+          <p:cNvSpPr txBox="1"/>
+          <p:nvPr/>
+        </p:nvSpPr>
+        <p:spPr>
+          <a:xfrm>
+            <a:off x="6309360" y="1280160"/>
+            <a:ext cx="5120640" cy="548640"/>
+          </a:xfrm>
+          <a:prstGeom prst="rect">
+            <a:avLst/>
+          </a:prstGeom>
+          <a:noFill/>
+        </p:spPr>
+        <p:txBody>
+          <a:bodyPr wrap="square">
+            <a:spAutoFit/>
+          </a:bodyPr>
+          <a:lstStyle/>
+          <a:p>
+            <a:pPr algn="l"/>
+            <a:r>
+              <a:rPr sz="2000" b="1">
+                <a:solidFill>
+                  <a:srgbClr val="128C8C"/>
+                </a:solidFill>
+                <a:latin typeface="Calibri"/>
+              </a:rPr>
+              <a:t>Underfitting</a:t>
+            </a:r>
+          </a:p>
+        </p:txBody>
+      </p:sp>
+      <p:sp>
+        <p:nvSpPr>
+          <p:cNvPr id="8" name="TextBox 7"/>
+          <p:cNvSpPr txBox="1"/>
+          <p:nvPr/>
+        </p:nvSpPr>
+        <p:spPr>
+          <a:xfrm>
+            <a:off x="6309360" y="1828800"/>
+            <a:ext cx="5120640" cy="4206240"/>
+          </a:xfrm>
+          <a:prstGeom prst="rect">
+            <a:avLst/>
+          </a:prstGeom>
+          <a:noFill/>
+        </p:spPr>
+        <p:txBody>
+          <a:bodyPr wrap="square">
+            <a:spAutoFit/>
+          </a:bodyPr>
+          <a:lstStyle/>
+          <a:p>
+            <a:pPr>
+              <a:spcAft>
+                <a:spcPts val="800"/>
+              </a:spcAft>
+            </a:pPr>
+            <a:r>
+              <a:rPr sz="1800">
+                <a:solidFill>
+                  <a:srgbClr val="1A1A1A"/>
+                </a:solidFill>
+                <a:latin typeface="Calibri"/>
+              </a:rPr>
+              <a:t>• Too simple for the pattern</a:t>
+            </a:r>
+          </a:p>
+          <a:p>
+            <a:pPr>
+              <a:spcAft>
+                <a:spcPts val="800"/>
+              </a:spcAft>
+            </a:pPr>
+            <a:r>
+              <a:rPr sz="1800">
+                <a:solidFill>
+                  <a:srgbClr val="1A1A1A"/>
+                </a:solidFill>
+                <a:latin typeface="Calibri"/>
+              </a:rPr>
+              <a:t>• Poor on BOTH train &amp; test</a:t>
+            </a:r>
+          </a:p>
+          <a:p>
+            <a:pPr>
+              <a:spcAft>
+                <a:spcPts val="800"/>
+              </a:spcAft>
+            </a:pPr>
+            <a:r>
+              <a:rPr sz="1800">
+                <a:solidFill>
+                  <a:srgbClr val="1A1A1A"/>
+                </a:solidFill>
+                <a:latin typeface="Calibri"/>
+              </a:rPr>
+              <a:t>• e.g. a line for a curve</a:t>
+            </a:r>
+          </a:p>
+        </p:txBody>
+      </p:sp>
+      <p:sp>
+        <p:nvSpPr>
+          <p:cNvPr id="9" name="TextBox 8"/>
+          <p:cNvSpPr txBox="1"/>
+          <p:nvPr/>
+        </p:nvSpPr>
+        <p:spPr>
+          <a:xfrm>
+            <a:off x="365760" y="6446520"/>
+            <a:ext cx="8229600" cy="365760"/>
+          </a:xfrm>
+          <a:prstGeom prst="rect">
+            <a:avLst/>
+          </a:prstGeom>
+          <a:noFill/>
+        </p:spPr>
+        <p:txBody>
+          <a:bodyPr wrap="square">
+            <a:spAutoFit/>
+          </a:bodyPr>
+          <a:lstStyle/>
+          <a:p>
+            <a:pPr algn="l"/>
+            <a:r>
+              <a:rPr sz="1000" b="0">
+                <a:solidFill>
+                  <a:srgbClr val="6B7280"/>
+                </a:solidFill>
+                <a:latin typeface="Calibri"/>
+              </a:rPr>
+              <a:t>Palomar College · CSCI 250 · Fall 2026</a:t>
+            </a:r>
+          </a:p>
+        </p:txBody>
+      </p:sp>
+      <p:sp>
+        <p:nvSpPr>
+          <p:cNvPr id="10" name="TextBox 9"/>
+          <p:cNvSpPr txBox="1"/>
+          <p:nvPr/>
+        </p:nvSpPr>
+        <p:spPr>
+          <a:xfrm>
+            <a:off x="11155680" y="6446520"/>
+            <a:ext cx="822960" cy="365760"/>
+          </a:xfrm>
+          <a:prstGeom prst="rect">
+            <a:avLst/>
+          </a:prstGeom>
+          <a:noFill/>
+        </p:spPr>
+        <p:txBody>
+          <a:bodyPr wrap="square">
+            <a:spAutoFit/>
+          </a:bodyPr>
+          <a:lstStyle/>
+          <a:p>
+            <a:pPr algn="r"/>
+            <a:r>
+              <a:rPr sz="1000" b="0">
+                <a:solidFill>
+                  <a:srgbClr val="6B7280"/>
+                </a:solidFill>
+                <a:latin typeface="Calibri"/>
+              </a:rPr>
+              <a:t>14/16</a:t>
+            </a:r>
+          </a:p>
+        </p:txBody>
+      </p:sp>
+    </p:spTree>
+  </p:cSld>
+  <p:clrMapOvr>
+    <a:masterClrMapping/>
+  </p:clrMapOvr>
+</p:sld>
+</file>
+
+<file path=ppt/slides/slide15.xml><?xml version="1.0" encoding="utf-8"?>
+<p:sld xmlns:a="http://schemas.openxmlformats.org/drawingml/2006/main" xmlns:p="http://schemas.openxmlformats.org/presentationml/2006/main" xmlns:r="http://schemas.openxmlformats.org/officeDocument/2006/relationships">
+  <p:cSld>
+    <p:bg>
+      <p:bgPr>
+        <a:solidFill>
+          <a:srgbClr val="FFFFFF"/>
+        </a:solidFill>
+        <a:effectLst/>
+      </p:bgPr>
+    </p:bg>
+    <p:spTree>
+      <p:nvGrpSpPr>
+        <p:cNvPr id="1" name=""/>
+        <p:cNvGrpSpPr/>
+        <p:nvPr/>
+      </p:nvGrpSpPr>
+      <p:grpSpPr/>
+      <p:sp>
+        <p:nvSpPr>
+          <p:cNvPr id="2" name="Rectangle 1"/>
+          <p:cNvSpPr/>
+          <p:nvPr/>
+        </p:nvSpPr>
+        <p:spPr>
+          <a:xfrm>
+            <a:off x="0" y="0"/>
+            <a:ext cx="12191695" cy="1051560"/>
+          </a:xfrm>
+          <a:prstGeom prst="rect">
+            <a:avLst/>
+          </a:prstGeom>
+          <a:solidFill>
+            <a:srgbClr val="0B1F3A"/>
+          </a:solidFill>
+          <a:ln>
+            <a:noFill/>
+          </a:ln>
+          <a:effectLst/>
+        </p:spPr>
+        <p:style>
+          <a:lnRef idx="1">
+            <a:schemeClr val="accent1"/>
+          </a:lnRef>
+          <a:fillRef idx="3">
+            <a:schemeClr val="accent1"/>
+          </a:fillRef>
+          <a:effectRef idx="2">
+            <a:schemeClr val="accent1"/>
+          </a:effectRef>
+          <a:fontRef idx="minor">
+            <a:schemeClr val="lt1"/>
+          </a:fontRef>
+        </p:style>
+        <p:txBody>
+          <a:bodyPr rtlCol="0" anchor="ctr"/>
+          <a:lstStyle/>
+          <a:p>
+            <a:pPr algn="ctr"/>
+          </a:p>
+        </p:txBody>
+      </p:sp>
+      <p:sp>
+        <p:nvSpPr>
+          <p:cNvPr id="3" name="Rectangle 2"/>
+          <p:cNvSpPr/>
+          <p:nvPr/>
+        </p:nvSpPr>
+        <p:spPr>
+          <a:xfrm>
+            <a:off x="0" y="1051560"/>
+            <a:ext cx="12191695" cy="54864"/>
+          </a:xfrm>
+          <a:prstGeom prst="rect">
+            <a:avLst/>
+          </a:prstGeom>
+          <a:solidFill>
+            <a:srgbClr val="128C8C"/>
+          </a:solidFill>
+          <a:ln>
+            <a:noFill/>
+          </a:ln>
+          <a:effectLst/>
+        </p:spPr>
+        <p:style>
+          <a:lnRef idx="1">
+            <a:schemeClr val="accent1"/>
+          </a:lnRef>
+          <a:fillRef idx="3">
+            <a:schemeClr val="accent1"/>
+          </a:fillRef>
+          <a:effectRef idx="2">
+            <a:schemeClr val="accent1"/>
+          </a:effectRef>
+          <a:fontRef idx="minor">
+            <a:schemeClr val="lt1"/>
+          </a:fontRef>
+        </p:style>
+        <p:txBody>
+          <a:bodyPr rtlCol="0" anchor="ctr"/>
+          <a:lstStyle/>
+          <a:p>
+            <a:pPr algn="ctr"/>
+          </a:p>
+        </p:txBody>
+      </p:sp>
+      <p:sp>
+        <p:nvSpPr>
+          <p:cNvPr id="4" name="TextBox 3"/>
+          <p:cNvSpPr txBox="1"/>
+          <p:nvPr/>
+        </p:nvSpPr>
+        <p:spPr>
+          <a:xfrm>
+            <a:off x="548640" y="201168"/>
+            <a:ext cx="11064240" cy="731520"/>
+          </a:xfrm>
+          <a:prstGeom prst="rect">
+            <a:avLst/>
+          </a:prstGeom>
+          <a:noFill/>
+        </p:spPr>
+        <p:txBody>
+          <a:bodyPr wrap="square" anchor="ctr">
+            <a:spAutoFit/>
+          </a:bodyPr>
+          <a:lstStyle/>
+          <a:p>
+            <a:pPr algn="l"/>
+            <a:r>
+              <a:rPr sz="2800" b="1">
+                <a:solidFill>
+                  <a:srgbClr val="FFFFFF"/>
+                </a:solidFill>
+                <a:latin typeface="Calibri"/>
+              </a:rPr>
+              <a:t>Regularization Fights Overfitting</a:t>
+            </a:r>
+          </a:p>
+        </p:txBody>
+      </p:sp>
+      <p:sp>
+        <p:nvSpPr>
+          <p:cNvPr id="5" name="Rectangle 4"/>
+          <p:cNvSpPr/>
+          <p:nvPr/>
+        </p:nvSpPr>
+        <p:spPr>
+          <a:xfrm>
+            <a:off x="548640" y="1325880"/>
+            <a:ext cx="11064240" cy="4480560"/>
+          </a:xfrm>
+          <a:prstGeom prst="rect">
+            <a:avLst/>
+          </a:prstGeom>
+          <a:solidFill>
+            <a:srgbClr val="1E1E1E"/>
+          </a:solidFill>
+          <a:ln>
+            <a:noFill/>
+          </a:ln>
+          <a:effectLst/>
+        </p:spPr>
+        <p:style>
+          <a:lnRef idx="1">
+            <a:schemeClr val="accent1"/>
+          </a:lnRef>
+          <a:fillRef idx="3">
+            <a:schemeClr val="accent1"/>
+          </a:fillRef>
+          <a:effectRef idx="2">
+            <a:schemeClr val="accent1"/>
+          </a:effectRef>
+          <a:fontRef idx="minor">
+            <a:schemeClr val="lt1"/>
+          </a:fontRef>
+        </p:style>
+        <p:txBody>
+          <a:bodyPr rtlCol="0" anchor="ctr" wrap="square" lIns="182880" tIns="137160"/>
+          <a:lstStyle/>
+          <a:p>
+            <a:pPr algn="ctr"/>
+            <a:r>
+              <a:rPr sz="1500">
+                <a:solidFill>
+                  <a:srgbClr val="E6E6E6"/>
+                </a:solidFill>
+                <a:latin typeface="Consolas"/>
+              </a:rPr>
+              <a:t># smaller C = stronger regularization</a:t>
+            </a:r>
+          </a:p>
+          <a:p>
+            <a:r>
+              <a:rPr sz="1500">
+                <a:solidFill>
+                  <a:srgbClr val="E6E6E6"/>
+                </a:solidFill>
+                <a:latin typeface="Consolas"/>
+              </a:rPr>
+              <a:t>LogisticRegression(C=0.1)</a:t>
+            </a:r>
+          </a:p>
+          <a:p>
+            <a:r>
+              <a:rPr sz="1500">
+                <a:solidFill>
+                  <a:srgbClr val="E6E6E6"/>
+                </a:solidFill>
+                <a:latin typeface="Consolas"/>
+              </a:rPr>
+              <a:t> </a:t>
+            </a:r>
+          </a:p>
+          <a:p>
+            <a:r>
+              <a:rPr sz="1500">
+                <a:solidFill>
+                  <a:srgbClr val="E6E6E6"/>
+                </a:solidFill>
+                <a:latin typeface="Consolas"/>
+              </a:rPr>
+              <a:t># shallower tree = less overfitting</a:t>
+            </a:r>
+          </a:p>
+          <a:p>
+            <a:r>
+              <a:rPr sz="1500">
+                <a:solidFill>
+                  <a:srgbClr val="E6E6E6"/>
+                </a:solidFill>
+                <a:latin typeface="Consolas"/>
+              </a:rPr>
+              <a:t>DecisionTreeClassifier(max_depth=3)</a:t>
+            </a:r>
+          </a:p>
+          <a:p>
+            <a:r>
+              <a:rPr sz="1500">
+                <a:solidFill>
+                  <a:srgbClr val="E6E6E6"/>
+                </a:solidFill>
+                <a:latin typeface="Consolas"/>
+              </a:rPr>
+              <a:t> </a:t>
+            </a:r>
+          </a:p>
+          <a:p>
+            <a:r>
+              <a:rPr sz="1500">
+                <a:solidFill>
+                  <a:srgbClr val="E6E6E6"/>
+                </a:solidFill>
+                <a:latin typeface="Consolas"/>
+              </a:rPr>
+              <a:t># larger k = smoother boundary</a:t>
+            </a:r>
+          </a:p>
+          <a:p>
+            <a:r>
+              <a:rPr sz="1500">
+                <a:solidFill>
+                  <a:srgbClr val="E6E6E6"/>
+                </a:solidFill>
+                <a:latin typeface="Consolas"/>
+              </a:rPr>
+              <a:t>KNeighborsClassifier(n_neighbors=15)</a:t>
+            </a:r>
+          </a:p>
+        </p:txBody>
+      </p:sp>
+      <p:sp>
+        <p:nvSpPr>
+          <p:cNvPr id="6" name="TextBox 5"/>
+          <p:cNvSpPr txBox="1"/>
+          <p:nvPr/>
+        </p:nvSpPr>
+        <p:spPr>
+          <a:xfrm>
+            <a:off x="548640" y="5897880"/>
+            <a:ext cx="10515600" cy="457200"/>
+          </a:xfrm>
+          <a:prstGeom prst="rect">
+            <a:avLst/>
+          </a:prstGeom>
+          <a:noFill/>
+        </p:spPr>
+        <p:txBody>
+          <a:bodyPr wrap="square">
+            <a:spAutoFit/>
+          </a:bodyPr>
+          <a:lstStyle/>
+          <a:p>
+            <a:pPr algn="l"/>
+            <a:r>
+              <a:rPr sz="1400" b="0">
+                <a:solidFill>
+                  <a:srgbClr val="6B7280"/>
+                </a:solidFill>
+                <a:latin typeface="Calibri"/>
+              </a:rPr>
+              <a:t>Tune for the train↔test GAP, not just the raw score</a:t>
+            </a:r>
+          </a:p>
+        </p:txBody>
+      </p:sp>
+      <p:sp>
+        <p:nvSpPr>
+          <p:cNvPr id="7" name="TextBox 6"/>
+          <p:cNvSpPr txBox="1"/>
+          <p:nvPr/>
+        </p:nvSpPr>
+        <p:spPr>
+          <a:xfrm>
+            <a:off x="365760" y="6446520"/>
+            <a:ext cx="8229600" cy="365760"/>
+          </a:xfrm>
+          <a:prstGeom prst="rect">
+            <a:avLst/>
+          </a:prstGeom>
+          <a:noFill/>
+        </p:spPr>
+        <p:txBody>
+          <a:bodyPr wrap="square">
+            <a:spAutoFit/>
+          </a:bodyPr>
+          <a:lstStyle/>
+          <a:p>
+            <a:pPr algn="l"/>
+            <a:r>
+              <a:rPr sz="1000" b="0">
+                <a:solidFill>
+                  <a:srgbClr val="6B7280"/>
+                </a:solidFill>
+                <a:latin typeface="Calibri"/>
+              </a:rPr>
+              <a:t>Palomar College · CSCI 250 · Fall 2026</a:t>
+            </a:r>
+          </a:p>
+        </p:txBody>
+      </p:sp>
+      <p:sp>
+        <p:nvSpPr>
+          <p:cNvPr id="8" name="TextBox 7"/>
+          <p:cNvSpPr txBox="1"/>
+          <p:nvPr/>
+        </p:nvSpPr>
+        <p:spPr>
+          <a:xfrm>
+            <a:off x="11155680" y="6446520"/>
+            <a:ext cx="822960" cy="365760"/>
+          </a:xfrm>
+          <a:prstGeom prst="rect">
+            <a:avLst/>
+          </a:prstGeom>
+          <a:noFill/>
+        </p:spPr>
+        <p:txBody>
+          <a:bodyPr wrap="square">
+            <a:spAutoFit/>
+          </a:bodyPr>
+          <a:lstStyle/>
+          <a:p>
+            <a:pPr algn="r"/>
+            <a:r>
+              <a:rPr sz="1000" b="0">
+                <a:solidFill>
+                  <a:srgbClr val="6B7280"/>
+                </a:solidFill>
+                <a:latin typeface="Calibri"/>
+              </a:rPr>
+              <a:t>15/16</a:t>
+            </a:r>
+          </a:p>
+        </p:txBody>
+      </p:sp>
+    </p:spTree>
+  </p:cSld>
+  <p:clrMapOvr>
+    <a:masterClrMapping/>
+  </p:clrMapOvr>
+</p:sld>
+</file>
+
+<file path=ppt/slides/slide16.xml><?xml version="1.0" encoding="utf-8"?>
 <p:sld xmlns:a="http://schemas.openxmlformats.org/drawingml/2006/main" xmlns:p="http://schemas.openxmlformats.org/presentationml/2006/main" xmlns:r="http://schemas.openxmlformats.org/officeDocument/2006/relationships">
   <p:cSld>
     <p:bg>
@@ -4678,7 +5375,7 @@
                 </a:solidFill>
                 <a:latin typeface="Calibri"/>
               </a:rPr>
-              <a:t>14/14</a:t>
+              <a:t>16/16</a:t>
             </a:r>
           </a:p>
         </p:txBody>
@@ -5000,7 +5697,7 @@
                 </a:solidFill>
                 <a:latin typeface="Calibri"/>
               </a:rPr>
-              <a:t>2/14</a:t>
+              <a:t>2/16</a:t>
             </a:r>
           </a:p>
         </p:txBody>
@@ -5456,7 +6153,7 @@
                 </a:solidFill>
                 <a:latin typeface="Calibri"/>
               </a:rPr>
-              <a:t>4/14</a:t>
+              <a:t>4/16</a:t>
             </a:r>
           </a:p>
         </p:txBody>
@@ -5887,7 +6584,7 @@
                 </a:solidFill>
                 <a:latin typeface="Calibri"/>
               </a:rPr>
-              <a:t>5/14</a:t>
+              <a:t>5/16</a:t>
             </a:r>
           </a:p>
         </p:txBody>
@@ -5901,6 +6598,328 @@
 </file>
 
 <file path=ppt/slides/slide6.xml><?xml version="1.0" encoding="utf-8"?>
+<p:sld xmlns:a="http://schemas.openxmlformats.org/drawingml/2006/main" xmlns:p="http://schemas.openxmlformats.org/presentationml/2006/main" xmlns:r="http://schemas.openxmlformats.org/officeDocument/2006/relationships">
+  <p:cSld>
+    <p:bg>
+      <p:bgPr>
+        <a:solidFill>
+          <a:srgbClr val="FFFFFF"/>
+        </a:solidFill>
+        <a:effectLst/>
+      </p:bgPr>
+    </p:bg>
+    <p:spTree>
+      <p:nvGrpSpPr>
+        <p:cNvPr id="1" name=""/>
+        <p:cNvGrpSpPr/>
+        <p:nvPr/>
+      </p:nvGrpSpPr>
+      <p:grpSpPr/>
+      <p:sp>
+        <p:nvSpPr>
+          <p:cNvPr id="2" name="Rectangle 1"/>
+          <p:cNvSpPr/>
+          <p:nvPr/>
+        </p:nvSpPr>
+        <p:spPr>
+          <a:xfrm>
+            <a:off x="0" y="0"/>
+            <a:ext cx="12191695" cy="1051560"/>
+          </a:xfrm>
+          <a:prstGeom prst="rect">
+            <a:avLst/>
+          </a:prstGeom>
+          <a:solidFill>
+            <a:srgbClr val="0B1F3A"/>
+          </a:solidFill>
+          <a:ln>
+            <a:noFill/>
+          </a:ln>
+          <a:effectLst/>
+        </p:spPr>
+        <p:style>
+          <a:lnRef idx="1">
+            <a:schemeClr val="accent1"/>
+          </a:lnRef>
+          <a:fillRef idx="3">
+            <a:schemeClr val="accent1"/>
+          </a:fillRef>
+          <a:effectRef idx="2">
+            <a:schemeClr val="accent1"/>
+          </a:effectRef>
+          <a:fontRef idx="minor">
+            <a:schemeClr val="lt1"/>
+          </a:fontRef>
+        </p:style>
+        <p:txBody>
+          <a:bodyPr rtlCol="0" anchor="ctr"/>
+          <a:lstStyle/>
+          <a:p>
+            <a:pPr algn="ctr"/>
+          </a:p>
+        </p:txBody>
+      </p:sp>
+      <p:sp>
+        <p:nvSpPr>
+          <p:cNvPr id="3" name="Rectangle 2"/>
+          <p:cNvSpPr/>
+          <p:nvPr/>
+        </p:nvSpPr>
+        <p:spPr>
+          <a:xfrm>
+            <a:off x="0" y="1051560"/>
+            <a:ext cx="12191695" cy="54864"/>
+          </a:xfrm>
+          <a:prstGeom prst="rect">
+            <a:avLst/>
+          </a:prstGeom>
+          <a:solidFill>
+            <a:srgbClr val="128C8C"/>
+          </a:solidFill>
+          <a:ln>
+            <a:noFill/>
+          </a:ln>
+          <a:effectLst/>
+        </p:spPr>
+        <p:style>
+          <a:lnRef idx="1">
+            <a:schemeClr val="accent1"/>
+          </a:lnRef>
+          <a:fillRef idx="3">
+            <a:schemeClr val="accent1"/>
+          </a:fillRef>
+          <a:effectRef idx="2">
+            <a:schemeClr val="accent1"/>
+          </a:effectRef>
+          <a:fontRef idx="minor">
+            <a:schemeClr val="lt1"/>
+          </a:fontRef>
+        </p:style>
+        <p:txBody>
+          <a:bodyPr rtlCol="0" anchor="ctr"/>
+          <a:lstStyle/>
+          <a:p>
+            <a:pPr algn="ctr"/>
+          </a:p>
+        </p:txBody>
+      </p:sp>
+      <p:sp>
+        <p:nvSpPr>
+          <p:cNvPr id="4" name="TextBox 3"/>
+          <p:cNvSpPr txBox="1"/>
+          <p:nvPr/>
+        </p:nvSpPr>
+        <p:spPr>
+          <a:xfrm>
+            <a:off x="548640" y="201168"/>
+            <a:ext cx="11064240" cy="731520"/>
+          </a:xfrm>
+          <a:prstGeom prst="rect">
+            <a:avLst/>
+          </a:prstGeom>
+          <a:noFill/>
+        </p:spPr>
+        <p:txBody>
+          <a:bodyPr wrap="square" anchor="ctr">
+            <a:spAutoFit/>
+          </a:bodyPr>
+          <a:lstStyle/>
+          <a:p>
+            <a:pPr algn="l"/>
+            <a:r>
+              <a:rPr sz="2800" b="1">
+                <a:solidFill>
+                  <a:srgbClr val="FFFFFF"/>
+                </a:solidFill>
+                <a:latin typeface="Calibri"/>
+              </a:rPr>
+              <a:t>Reading the Coefficients (reg.coef_)</a:t>
+            </a:r>
+          </a:p>
+        </p:txBody>
+      </p:sp>
+      <p:sp>
+        <p:nvSpPr>
+          <p:cNvPr id="5" name="TextBox 4"/>
+          <p:cNvSpPr txBox="1"/>
+          <p:nvPr/>
+        </p:nvSpPr>
+        <p:spPr>
+          <a:xfrm>
+            <a:off x="731520" y="1371600"/>
+            <a:ext cx="10698480" cy="4754880"/>
+          </a:xfrm>
+          <a:prstGeom prst="rect">
+            <a:avLst/>
+          </a:prstGeom>
+          <a:noFill/>
+        </p:spPr>
+        <p:txBody>
+          <a:bodyPr wrap="square">
+            <a:spAutoFit/>
+          </a:bodyPr>
+          <a:lstStyle/>
+          <a:p>
+            <a:pPr>
+              <a:spcAft>
+                <a:spcPts val="800"/>
+              </a:spcAft>
+            </a:pPr>
+            <a:r>
+              <a:rPr sz="2000">
+                <a:solidFill>
+                  <a:srgbClr val="1A1A1A"/>
+                </a:solidFill>
+                <a:latin typeface="Calibri"/>
+              </a:rPr>
+              <a:t>• One weight per feature (+ intercept)</a:t>
+            </a:r>
+          </a:p>
+          <a:p>
+            <a:pPr>
+              <a:spcAft>
+                <a:spcPts val="800"/>
+              </a:spcAft>
+            </a:pPr>
+            <a:r>
+              <a:rPr sz="2000">
+                <a:solidFill>
+                  <a:srgbClr val="1A1A1A"/>
+                </a:solidFill>
+                <a:latin typeface="Calibri"/>
+              </a:rPr>
+              <a:t>• Change in target per one-unit rise in that feature, others fixed</a:t>
+            </a:r>
+          </a:p>
+          <a:p>
+            <a:pPr>
+              <a:spcAft>
+                <a:spcPts val="800"/>
+              </a:spcAft>
+            </a:pPr>
+            <a:r>
+              <a:rPr sz="2000">
+                <a:solidFill>
+                  <a:srgbClr val="1A1A1A"/>
+                </a:solidFill>
+                <a:latin typeface="Calibri"/>
+              </a:rPr>
+              <a:t>• Sign = direction (up/down); magnitude = strength of pull</a:t>
+            </a:r>
+          </a:p>
+          <a:p>
+            <a:pPr>
+              <a:spcAft>
+                <a:spcPts val="800"/>
+              </a:spcAft>
+            </a:pPr>
+            <a:r>
+              <a:rPr sz="2000">
+                <a:solidFill>
+                  <a:srgbClr val="1A1A1A"/>
+                </a:solidFill>
+                <a:latin typeface="Calibri"/>
+              </a:rPr>
+              <a:t>• Largest |coef| = most influential feature for this model</a:t>
+            </a:r>
+          </a:p>
+          <a:p>
+            <a:pPr lvl="1">
+              <a:spcAft>
+                <a:spcPts val="800"/>
+              </a:spcAft>
+            </a:pPr>
+            <a:r>
+              <a:rPr sz="1800">
+                <a:solidFill>
+                  <a:srgbClr val="6B7280"/>
+                </a:solidFill>
+                <a:latin typeface="Calibri"/>
+              </a:rPr>
+              <a:t>– Association, not causation — and compare magnitudes only when scaled</a:t>
+            </a:r>
+          </a:p>
+        </p:txBody>
+      </p:sp>
+      <p:sp>
+        <p:nvSpPr>
+          <p:cNvPr id="6" name="TextBox 5"/>
+          <p:cNvSpPr txBox="1"/>
+          <p:nvPr/>
+        </p:nvSpPr>
+        <p:spPr>
+          <a:xfrm>
+            <a:off x="365760" y="6446520"/>
+            <a:ext cx="8229600" cy="365760"/>
+          </a:xfrm>
+          <a:prstGeom prst="rect">
+            <a:avLst/>
+          </a:prstGeom>
+          <a:noFill/>
+        </p:spPr>
+        <p:txBody>
+          <a:bodyPr wrap="square">
+            <a:spAutoFit/>
+          </a:bodyPr>
+          <a:lstStyle/>
+          <a:p>
+            <a:pPr algn="l"/>
+            <a:r>
+              <a:rPr sz="1000" b="0">
+                <a:solidFill>
+                  <a:srgbClr val="6B7280"/>
+                </a:solidFill>
+                <a:latin typeface="Calibri"/>
+              </a:rPr>
+              <a:t>Palomar College · CSCI 250 · Fall 2026</a:t>
+            </a:r>
+          </a:p>
+        </p:txBody>
+      </p:sp>
+      <p:sp>
+        <p:nvSpPr>
+          <p:cNvPr id="7" name="TextBox 6"/>
+          <p:cNvSpPr txBox="1"/>
+          <p:nvPr/>
+        </p:nvSpPr>
+        <p:spPr>
+          <a:xfrm>
+            <a:off x="11155680" y="6446520"/>
+            <a:ext cx="822960" cy="365760"/>
+          </a:xfrm>
+          <a:prstGeom prst="rect">
+            <a:avLst/>
+          </a:prstGeom>
+          <a:noFill/>
+        </p:spPr>
+        <p:txBody>
+          <a:bodyPr wrap="square">
+            <a:spAutoFit/>
+          </a:bodyPr>
+          <a:lstStyle/>
+          <a:p>
+            <a:pPr algn="r"/>
+            <a:r>
+              <a:rPr sz="1000" b="0">
+                <a:solidFill>
+                  <a:srgbClr val="6B7280"/>
+                </a:solidFill>
+                <a:latin typeface="Calibri"/>
+              </a:rPr>
+              <a:t>6/16</a:t>
+            </a:r>
+          </a:p>
+        </p:txBody>
+      </p:sp>
+    </p:spTree>
+  </p:cSld>
+  <p:clrMapOvr>
+    <a:masterClrMapping/>
+  </p:clrMapOvr>
+</p:sld>
+</file>
+
+<file path=ppt/slides/slide7.xml><?xml version="1.0" encoding="utf-8"?>
 <p:sld xmlns:a="http://schemas.openxmlformats.org/drawingml/2006/main" xmlns:p="http://schemas.openxmlformats.org/presentationml/2006/main" xmlns:r="http://schemas.openxmlformats.org/officeDocument/2006/relationships">
   <p:cSld>
     <p:bg>
@@ -5949,437 +6968,6 @@
                 <a:latin typeface="Calibri"/>
               </a:rPr>
               <a:t>Classification — Predicting a Category</a:t>
-            </a:r>
-          </a:p>
-        </p:txBody>
-      </p:sp>
-    </p:spTree>
-  </p:cSld>
-  <p:clrMapOvr>
-    <a:masterClrMapping/>
-  </p:clrMapOvr>
-</p:sld>
-</file>
-
-<file path=ppt/slides/slide7.xml><?xml version="1.0" encoding="utf-8"?>
-<p:sld xmlns:a="http://schemas.openxmlformats.org/drawingml/2006/main" xmlns:p="http://schemas.openxmlformats.org/presentationml/2006/main" xmlns:r="http://schemas.openxmlformats.org/officeDocument/2006/relationships">
-  <p:cSld>
-    <p:bg>
-      <p:bgPr>
-        <a:solidFill>
-          <a:srgbClr val="FFFFFF"/>
-        </a:solidFill>
-        <a:effectLst/>
-      </p:bgPr>
-    </p:bg>
-    <p:spTree>
-      <p:nvGrpSpPr>
-        <p:cNvPr id="1" name=""/>
-        <p:cNvGrpSpPr/>
-        <p:nvPr/>
-      </p:nvGrpSpPr>
-      <p:grpSpPr/>
-      <p:sp>
-        <p:nvSpPr>
-          <p:cNvPr id="2" name="Rectangle 1"/>
-          <p:cNvSpPr/>
-          <p:nvPr/>
-        </p:nvSpPr>
-        <p:spPr>
-          <a:xfrm>
-            <a:off x="0" y="0"/>
-            <a:ext cx="12191695" cy="1051560"/>
-          </a:xfrm>
-          <a:prstGeom prst="rect">
-            <a:avLst/>
-          </a:prstGeom>
-          <a:solidFill>
-            <a:srgbClr val="0B1F3A"/>
-          </a:solidFill>
-          <a:ln>
-            <a:noFill/>
-          </a:ln>
-          <a:effectLst/>
-        </p:spPr>
-        <p:style>
-          <a:lnRef idx="1">
-            <a:schemeClr val="accent1"/>
-          </a:lnRef>
-          <a:fillRef idx="3">
-            <a:schemeClr val="accent1"/>
-          </a:fillRef>
-          <a:effectRef idx="2">
-            <a:schemeClr val="accent1"/>
-          </a:effectRef>
-          <a:fontRef idx="minor">
-            <a:schemeClr val="lt1"/>
-          </a:fontRef>
-        </p:style>
-        <p:txBody>
-          <a:bodyPr rtlCol="0" anchor="ctr"/>
-          <a:lstStyle/>
-          <a:p>
-            <a:pPr algn="ctr"/>
-          </a:p>
-        </p:txBody>
-      </p:sp>
-      <p:sp>
-        <p:nvSpPr>
-          <p:cNvPr id="3" name="Rectangle 2"/>
-          <p:cNvSpPr/>
-          <p:nvPr/>
-        </p:nvSpPr>
-        <p:spPr>
-          <a:xfrm>
-            <a:off x="0" y="1051560"/>
-            <a:ext cx="12191695" cy="54864"/>
-          </a:xfrm>
-          <a:prstGeom prst="rect">
-            <a:avLst/>
-          </a:prstGeom>
-          <a:solidFill>
-            <a:srgbClr val="128C8C"/>
-          </a:solidFill>
-          <a:ln>
-            <a:noFill/>
-          </a:ln>
-          <a:effectLst/>
-        </p:spPr>
-        <p:style>
-          <a:lnRef idx="1">
-            <a:schemeClr val="accent1"/>
-          </a:lnRef>
-          <a:fillRef idx="3">
-            <a:schemeClr val="accent1"/>
-          </a:fillRef>
-          <a:effectRef idx="2">
-            <a:schemeClr val="accent1"/>
-          </a:effectRef>
-          <a:fontRef idx="minor">
-            <a:schemeClr val="lt1"/>
-          </a:fontRef>
-        </p:style>
-        <p:txBody>
-          <a:bodyPr rtlCol="0" anchor="ctr"/>
-          <a:lstStyle/>
-          <a:p>
-            <a:pPr algn="ctr"/>
-          </a:p>
-        </p:txBody>
-      </p:sp>
-      <p:sp>
-        <p:nvSpPr>
-          <p:cNvPr id="4" name="TextBox 3"/>
-          <p:cNvSpPr txBox="1"/>
-          <p:nvPr/>
-        </p:nvSpPr>
-        <p:spPr>
-          <a:xfrm>
-            <a:off x="548640" y="201168"/>
-            <a:ext cx="11064240" cy="731520"/>
-          </a:xfrm>
-          <a:prstGeom prst="rect">
-            <a:avLst/>
-          </a:prstGeom>
-          <a:noFill/>
-        </p:spPr>
-        <p:txBody>
-          <a:bodyPr wrap="square" anchor="ctr">
-            <a:spAutoFit/>
-          </a:bodyPr>
-          <a:lstStyle/>
-          <a:p>
-            <a:pPr algn="l"/>
-            <a:r>
-              <a:rPr sz="2800" b="1">
-                <a:solidFill>
-                  <a:srgbClr val="FFFFFF"/>
-                </a:solidFill>
-                <a:latin typeface="Calibri"/>
-              </a:rPr>
-              <a:t>Three Workhorse Classifiers</a:t>
-            </a:r>
-          </a:p>
-        </p:txBody>
-      </p:sp>
-      <p:sp>
-        <p:nvSpPr>
-          <p:cNvPr id="5" name="TextBox 4"/>
-          <p:cNvSpPr txBox="1"/>
-          <p:nvPr/>
-        </p:nvSpPr>
-        <p:spPr>
-          <a:xfrm>
-            <a:off x="731520" y="1280160"/>
-            <a:ext cx="5120640" cy="548640"/>
-          </a:xfrm>
-          <a:prstGeom prst="rect">
-            <a:avLst/>
-          </a:prstGeom>
-          <a:noFill/>
-        </p:spPr>
-        <p:txBody>
-          <a:bodyPr wrap="square">
-            <a:spAutoFit/>
-          </a:bodyPr>
-          <a:lstStyle/>
-          <a:p>
-            <a:pPr algn="l"/>
-            <a:r>
-              <a:rPr sz="2000" b="1">
-                <a:solidFill>
-                  <a:srgbClr val="128C8C"/>
-                </a:solidFill>
-                <a:latin typeface="Calibri"/>
-              </a:rPr>
-              <a:t>Linear baseline</a:t>
-            </a:r>
-          </a:p>
-        </p:txBody>
-      </p:sp>
-      <p:sp>
-        <p:nvSpPr>
-          <p:cNvPr id="6" name="TextBox 5"/>
-          <p:cNvSpPr txBox="1"/>
-          <p:nvPr/>
-        </p:nvSpPr>
-        <p:spPr>
-          <a:xfrm>
-            <a:off x="731520" y="1828800"/>
-            <a:ext cx="5120640" cy="4206240"/>
-          </a:xfrm>
-          <a:prstGeom prst="rect">
-            <a:avLst/>
-          </a:prstGeom>
-          <a:noFill/>
-        </p:spPr>
-        <p:txBody>
-          <a:bodyPr wrap="square">
-            <a:spAutoFit/>
-          </a:bodyPr>
-          <a:lstStyle/>
-          <a:p>
-            <a:pPr>
-              <a:spcAft>
-                <a:spcPts val="800"/>
-              </a:spcAft>
-            </a:pPr>
-            <a:r>
-              <a:rPr sz="1800">
-                <a:solidFill>
-                  <a:srgbClr val="1A1A1A"/>
-                </a:solidFill>
-                <a:latin typeface="Calibri"/>
-              </a:rPr>
-              <a:t>• Logistic regression</a:t>
-            </a:r>
-          </a:p>
-          <a:p>
-            <a:pPr>
-              <a:spcAft>
-                <a:spcPts val="800"/>
-              </a:spcAft>
-            </a:pPr>
-            <a:r>
-              <a:rPr sz="1800">
-                <a:solidFill>
-                  <a:srgbClr val="1A1A1A"/>
-                </a:solidFill>
-                <a:latin typeface="Calibri"/>
-              </a:rPr>
-              <a:t>• Outputs class probabilities</a:t>
-            </a:r>
-          </a:p>
-          <a:p>
-            <a:pPr>
-              <a:spcAft>
-                <a:spcPts val="800"/>
-              </a:spcAft>
-            </a:pPr>
-            <a:r>
-              <a:rPr sz="1800">
-                <a:solidFill>
-                  <a:srgbClr val="1A1A1A"/>
-                </a:solidFill>
-                <a:latin typeface="Calibri"/>
-              </a:rPr>
-              <a:t>• Strong, fast, interpretable</a:t>
-            </a:r>
-          </a:p>
-        </p:txBody>
-      </p:sp>
-      <p:sp>
-        <p:nvSpPr>
-          <p:cNvPr id="7" name="TextBox 6"/>
-          <p:cNvSpPr txBox="1"/>
-          <p:nvPr/>
-        </p:nvSpPr>
-        <p:spPr>
-          <a:xfrm>
-            <a:off x="6309360" y="1280160"/>
-            <a:ext cx="5120640" cy="548640"/>
-          </a:xfrm>
-          <a:prstGeom prst="rect">
-            <a:avLst/>
-          </a:prstGeom>
-          <a:noFill/>
-        </p:spPr>
-        <p:txBody>
-          <a:bodyPr wrap="square">
-            <a:spAutoFit/>
-          </a:bodyPr>
-          <a:lstStyle/>
-          <a:p>
-            <a:pPr algn="l"/>
-            <a:r>
-              <a:rPr sz="2000" b="1">
-                <a:solidFill>
-                  <a:srgbClr val="128C8C"/>
-                </a:solidFill>
-                <a:latin typeface="Calibri"/>
-              </a:rPr>
-              <a:t>Instance &amp; rule based</a:t>
-            </a:r>
-          </a:p>
-        </p:txBody>
-      </p:sp>
-      <p:sp>
-        <p:nvSpPr>
-          <p:cNvPr id="8" name="TextBox 7"/>
-          <p:cNvSpPr txBox="1"/>
-          <p:nvPr/>
-        </p:nvSpPr>
-        <p:spPr>
-          <a:xfrm>
-            <a:off x="6309360" y="1828800"/>
-            <a:ext cx="5120640" cy="4206240"/>
-          </a:xfrm>
-          <a:prstGeom prst="rect">
-            <a:avLst/>
-          </a:prstGeom>
-          <a:noFill/>
-        </p:spPr>
-        <p:txBody>
-          <a:bodyPr wrap="square">
-            <a:spAutoFit/>
-          </a:bodyPr>
-          <a:lstStyle/>
-          <a:p>
-            <a:pPr>
-              <a:spcAft>
-                <a:spcPts val="800"/>
-              </a:spcAft>
-            </a:pPr>
-            <a:r>
-              <a:rPr sz="1800">
-                <a:solidFill>
-                  <a:srgbClr val="1A1A1A"/>
-                </a:solidFill>
-                <a:latin typeface="Calibri"/>
-              </a:rPr>
-              <a:t>• k-NN: vote of k neighbors</a:t>
-            </a:r>
-          </a:p>
-          <a:p>
-            <a:pPr>
-              <a:spcAft>
-                <a:spcPts val="800"/>
-              </a:spcAft>
-            </a:pPr>
-            <a:r>
-              <a:rPr sz="1800">
-                <a:solidFill>
-                  <a:srgbClr val="1A1A1A"/>
-                </a:solidFill>
-                <a:latin typeface="Calibri"/>
-              </a:rPr>
-              <a:t>• Decision tree: yes/no flowchart</a:t>
-            </a:r>
-          </a:p>
-          <a:p>
-            <a:pPr>
-              <a:spcAft>
-                <a:spcPts val="800"/>
-              </a:spcAft>
-            </a:pPr>
-            <a:r>
-              <a:rPr sz="1800">
-                <a:solidFill>
-                  <a:srgbClr val="1A1A1A"/>
-                </a:solidFill>
-                <a:latin typeface="Calibri"/>
-              </a:rPr>
-              <a:t>• Trees overfit if too deep</a:t>
-            </a:r>
-          </a:p>
-        </p:txBody>
-      </p:sp>
-      <p:sp>
-        <p:nvSpPr>
-          <p:cNvPr id="9" name="TextBox 8"/>
-          <p:cNvSpPr txBox="1"/>
-          <p:nvPr/>
-        </p:nvSpPr>
-        <p:spPr>
-          <a:xfrm>
-            <a:off x="365760" y="6446520"/>
-            <a:ext cx="8229600" cy="365760"/>
-          </a:xfrm>
-          <a:prstGeom prst="rect">
-            <a:avLst/>
-          </a:prstGeom>
-          <a:noFill/>
-        </p:spPr>
-        <p:txBody>
-          <a:bodyPr wrap="square">
-            <a:spAutoFit/>
-          </a:bodyPr>
-          <a:lstStyle/>
-          <a:p>
-            <a:pPr algn="l"/>
-            <a:r>
-              <a:rPr sz="1000" b="0">
-                <a:solidFill>
-                  <a:srgbClr val="6B7280"/>
-                </a:solidFill>
-                <a:latin typeface="Calibri"/>
-              </a:rPr>
-              <a:t>Palomar College · CSCI 250 · Fall 2026</a:t>
-            </a:r>
-          </a:p>
-        </p:txBody>
-      </p:sp>
-      <p:sp>
-        <p:nvSpPr>
-          <p:cNvPr id="10" name="TextBox 9"/>
-          <p:cNvSpPr txBox="1"/>
-          <p:nvPr/>
-        </p:nvSpPr>
-        <p:spPr>
-          <a:xfrm>
-            <a:off x="11155680" y="6446520"/>
-            <a:ext cx="822960" cy="365760"/>
-          </a:xfrm>
-          <a:prstGeom prst="rect">
-            <a:avLst/>
-          </a:prstGeom>
-          <a:noFill/>
-        </p:spPr>
-        <p:txBody>
-          <a:bodyPr wrap="square">
-            <a:spAutoFit/>
-          </a:bodyPr>
-          <a:lstStyle/>
-          <a:p>
-            <a:pPr algn="r"/>
-            <a:r>
-              <a:rPr sz="1000" b="0">
-                <a:solidFill>
-                  <a:srgbClr val="6B7280"/>
-                </a:solidFill>
-                <a:latin typeface="Calibri"/>
-              </a:rPr>
-              <a:t>7/14</a:t>
             </a:r>
           </a:p>
         </p:txBody>
@@ -6528,7 +7116,7 @@
                 </a:solidFill>
                 <a:latin typeface="Calibri"/>
               </a:rPr>
-              <a:t>When Accuracy Lies</a:t>
+              <a:t>Three Workhorse Classifiers</a:t>
             </a:r>
           </a:p>
         </p:txBody>
@@ -6541,8 +7129,43 @@
         </p:nvSpPr>
         <p:spPr>
           <a:xfrm>
-            <a:off x="731520" y="1371600"/>
-            <a:ext cx="10698480" cy="4754880"/>
+            <a:off x="731520" y="1280160"/>
+            <a:ext cx="5120640" cy="548640"/>
+          </a:xfrm>
+          <a:prstGeom prst="rect">
+            <a:avLst/>
+          </a:prstGeom>
+          <a:noFill/>
+        </p:spPr>
+        <p:txBody>
+          <a:bodyPr wrap="square">
+            <a:spAutoFit/>
+          </a:bodyPr>
+          <a:lstStyle/>
+          <a:p>
+            <a:pPr algn="l"/>
+            <a:r>
+              <a:rPr sz="2000" b="1">
+                <a:solidFill>
+                  <a:srgbClr val="128C8C"/>
+                </a:solidFill>
+                <a:latin typeface="Calibri"/>
+              </a:rPr>
+              <a:t>Linear baseline</a:t>
+            </a:r>
+          </a:p>
+        </p:txBody>
+      </p:sp>
+      <p:sp>
+        <p:nvSpPr>
+          <p:cNvPr id="6" name="TextBox 5"/>
+          <p:cNvSpPr txBox="1"/>
+          <p:nvPr/>
+        </p:nvSpPr>
+        <p:spPr>
+          <a:xfrm>
+            <a:off x="731520" y="1828800"/>
+            <a:ext cx="5120640" cy="4206240"/>
           </a:xfrm>
           <a:prstGeom prst="rect">
             <a:avLst/>
@@ -6561,13 +7184,13 @@
               </a:spcAft>
             </a:pPr>
             <a:r>
-              <a:rPr sz="2000">
+              <a:rPr sz="1800">
                 <a:solidFill>
                   <a:srgbClr val="1A1A1A"/>
                 </a:solidFill>
                 <a:latin typeface="Calibri"/>
               </a:rPr>
-              <a:t>• Accuracy = fraction correct — fine only if classes are balanced</a:t>
+              <a:t>• Logistic regression</a:t>
             </a:r>
           </a:p>
           <a:p>
@@ -6577,13 +7200,13 @@
               </a:spcAft>
             </a:pPr>
             <a:r>
-              <a:rPr sz="2000">
+              <a:rPr sz="1800">
                 <a:solidFill>
                   <a:srgbClr val="1A1A1A"/>
                 </a:solidFill>
                 <a:latin typeface="Calibri"/>
               </a:rPr>
-              <a:t>• 99% not-spam? 'always not-spam' = 99% accurate and useless</a:t>
+              <a:t>• Outputs class probabilities</a:t>
             </a:r>
           </a:p>
           <a:p>
@@ -6593,15 +7216,73 @@
               </a:spcAft>
             </a:pPr>
             <a:r>
-              <a:rPr sz="2000">
+              <a:rPr sz="1800">
                 <a:solidFill>
                   <a:srgbClr val="1A1A1A"/>
                 </a:solidFill>
                 <a:latin typeface="Calibri"/>
               </a:rPr>
-              <a:t>• Precision = of flagged positives, how many were right</a:t>
-            </a:r>
-          </a:p>
+              <a:t>• Strong, fast, interpretable</a:t>
+            </a:r>
+          </a:p>
+        </p:txBody>
+      </p:sp>
+      <p:sp>
+        <p:nvSpPr>
+          <p:cNvPr id="7" name="TextBox 6"/>
+          <p:cNvSpPr txBox="1"/>
+          <p:nvPr/>
+        </p:nvSpPr>
+        <p:spPr>
+          <a:xfrm>
+            <a:off x="6309360" y="1280160"/>
+            <a:ext cx="5120640" cy="548640"/>
+          </a:xfrm>
+          <a:prstGeom prst="rect">
+            <a:avLst/>
+          </a:prstGeom>
+          <a:noFill/>
+        </p:spPr>
+        <p:txBody>
+          <a:bodyPr wrap="square">
+            <a:spAutoFit/>
+          </a:bodyPr>
+          <a:lstStyle/>
+          <a:p>
+            <a:pPr algn="l"/>
+            <a:r>
+              <a:rPr sz="2000" b="1">
+                <a:solidFill>
+                  <a:srgbClr val="128C8C"/>
+                </a:solidFill>
+                <a:latin typeface="Calibri"/>
+              </a:rPr>
+              <a:t>Instance &amp; rule based</a:t>
+            </a:r>
+          </a:p>
+        </p:txBody>
+      </p:sp>
+      <p:sp>
+        <p:nvSpPr>
+          <p:cNvPr id="8" name="TextBox 7"/>
+          <p:cNvSpPr txBox="1"/>
+          <p:nvPr/>
+        </p:nvSpPr>
+        <p:spPr>
+          <a:xfrm>
+            <a:off x="6309360" y="1828800"/>
+            <a:ext cx="5120640" cy="4206240"/>
+          </a:xfrm>
+          <a:prstGeom prst="rect">
+            <a:avLst/>
+          </a:prstGeom>
+          <a:noFill/>
+        </p:spPr>
+        <p:txBody>
+          <a:bodyPr wrap="square">
+            <a:spAutoFit/>
+          </a:bodyPr>
+          <a:lstStyle/>
           <a:p>
             <a:pPr>
               <a:spcAft>
@@ -6609,17 +7290,17 @@
               </a:spcAft>
             </a:pPr>
             <a:r>
-              <a:rPr sz="2000">
+              <a:rPr sz="1800">
                 <a:solidFill>
                   <a:srgbClr val="1A1A1A"/>
                 </a:solidFill>
                 <a:latin typeface="Calibri"/>
               </a:rPr>
-              <a:t>• Recall = of actual positives, how many we caught</a:t>
-            </a:r>
-          </a:p>
-          <a:p>
-            <a:pPr lvl="1">
+              <a:t>• k-NN: vote of k neighbors</a:t>
+            </a:r>
+          </a:p>
+          <a:p>
+            <a:pPr>
               <a:spcAft>
                 <a:spcPts val="800"/>
               </a:spcAft>
@@ -6627,18 +7308,34 @@
             <a:r>
               <a:rPr sz="1800">
                 <a:solidFill>
-                  <a:srgbClr val="6B7280"/>
-                </a:solidFill>
-                <a:latin typeface="Calibri"/>
-              </a:rPr>
-              <a:t>– F1 = harmonic mean of precision &amp; recall (one number)</a:t>
-            </a:r>
-          </a:p>
-        </p:txBody>
-      </p:sp>
-      <p:sp>
-        <p:nvSpPr>
-          <p:cNvPr id="6" name="TextBox 5"/>
+                  <a:srgbClr val="1A1A1A"/>
+                </a:solidFill>
+                <a:latin typeface="Calibri"/>
+              </a:rPr>
+              <a:t>• Decision tree: yes/no flowchart</a:t>
+            </a:r>
+          </a:p>
+          <a:p>
+            <a:pPr>
+              <a:spcAft>
+                <a:spcPts val="800"/>
+              </a:spcAft>
+            </a:pPr>
+            <a:r>
+              <a:rPr sz="1800">
+                <a:solidFill>
+                  <a:srgbClr val="1A1A1A"/>
+                </a:solidFill>
+                <a:latin typeface="Calibri"/>
+              </a:rPr>
+              <a:t>• Trees overfit if too deep</a:t>
+            </a:r>
+          </a:p>
+        </p:txBody>
+      </p:sp>
+      <p:sp>
+        <p:nvSpPr>
+          <p:cNvPr id="9" name="TextBox 8"/>
           <p:cNvSpPr txBox="1"/>
           <p:nvPr/>
         </p:nvSpPr>
@@ -6673,7 +7370,7 @@
       </p:sp>
       <p:sp>
         <p:nvSpPr>
-          <p:cNvPr id="7" name="TextBox 6"/>
+          <p:cNvPr id="10" name="TextBox 9"/>
           <p:cNvSpPr txBox="1"/>
           <p:nvPr/>
         </p:nvSpPr>
@@ -6701,7 +7398,7 @@
                 </a:solidFill>
                 <a:latin typeface="Calibri"/>
               </a:rPr>
-              <a:t>8/14</a:t>
+              <a:t>8/16</a:t>
             </a:r>
           </a:p>
         </p:txBody>
@@ -6850,7 +7547,7 @@
                 </a:solidFill>
                 <a:latin typeface="Calibri"/>
               </a:rPr>
-              <a:t>Classifier Metrics in sklearn</a:t>
+              <a:t>Feature Scaling: Why k-NN Needs It</a:t>
             </a:r>
           </a:p>
         </p:txBody>
@@ -6903,7 +7600,7 @@
                 </a:solidFill>
                 <a:latin typeface="Consolas"/>
               </a:rPr>
-              <a:t>from sklearn.metrics import (classification_report,</a:t>
+              <a:t>from sklearn.preprocessing import StandardScaler</a:t>
             </a:r>
           </a:p>
           <a:p>
@@ -6914,7 +7611,7 @@
                 </a:solidFill>
                 <a:latin typeface="Consolas"/>
               </a:rPr>
-              <a:t>                             confusion_matrix)</a:t>
+              <a:t>from sklearn.pipeline import make_pipeline</a:t>
             </a:r>
           </a:p>
           <a:p>
@@ -6936,7 +7633,7 @@
                 </a:solidFill>
                 <a:latin typeface="Consolas"/>
               </a:rPr>
-              <a:t>clf.fit(X_train, y_train)</a:t>
+              <a:t># k-NN votes by DISTANCE -&gt; a big-range feature dominates</a:t>
             </a:r>
           </a:p>
           <a:p>
@@ -6947,7 +7644,7 @@
                 </a:solidFill>
                 <a:latin typeface="Consolas"/>
               </a:rPr>
-              <a:t>p = clf.predict(X_test)</a:t>
+              <a:t>knn = make_pipeline(StandardScaler(),       # mean 0, std 1</a:t>
             </a:r>
           </a:p>
           <a:p>
@@ -6958,7 +7655,7 @@
                 </a:solidFill>
                 <a:latin typeface="Consolas"/>
               </a:rPr>
-              <a:t>print(classification_report(y_test, p))</a:t>
+              <a:t>                    KNeighborsClassifier(n_neighbors=5))</a:t>
             </a:r>
           </a:p>
           <a:p>
@@ -6969,7 +7666,7 @@
                 </a:solidFill>
                 <a:latin typeface="Consolas"/>
               </a:rPr>
-              <a:t>print(confusion_matrix(y_test, p))</a:t>
+              <a:t># same k-NN scores HIGHER with scaling (see notebook 2)</a:t>
             </a:r>
           </a:p>
         </p:txBody>
@@ -7004,7 +7701,7 @@
                 </a:solidFill>
                 <a:latin typeface="Calibri"/>
               </a:rPr>
-              <a:t>Confusion matrix shows WHICH classes get confused — not just how many</a:t>
+              <a:t>Scale for k-NN / SVM / neural nets. Trees split one feature at a time — scale-invariant.</a:t>
             </a:r>
           </a:p>
         </p:txBody>
@@ -7074,7 +7771,7 @@
                 </a:solidFill>
                 <a:latin typeface="Calibri"/>
               </a:rPr>
-              <a:t>9/14</a:t>
+              <a:t>9/16</a:t>
             </a:r>
           </a:p>
         </p:txBody>

</xml_diff>